<commit_message>
Add try-it slide and speaking notes; describe ASP as a prototype implementation
The deck gains a "Try it yourself" slide with the live app URL and the six
dashboard tabs, each with a one-line caption. Every slide's notes now open
with a short SAY block for recording, followed by the full notes. Includes
the LinkedIn link on the title slide.

The README tagline now reads "a prototype implementation of ASP", which is
more accurate than "ASP-inspired" without claiming the full reference
monitor properties.
</commit_message>
<xml_diff>
--- a/docs/source-materials/SwarmSentinel-v3---Live-Containment.pptx
+++ b/docs/source-materials/SwarmSentinel-v3---Live-Containment.pptx
@@ -5,7 +5,7 @@
     <p:sldMasterId id="2147483648" r:id="rId1"/>
   </p:sldMasterIdLst>
   <p:notesMasterIdLst>
-    <p:notesMasterId r:id="rId16"/>
+    <p:notesMasterId r:id="rId18"/>
   </p:notesMasterIdLst>
   <p:sldIdLst>
     <p:sldId id="256" r:id="rId2"/>
@@ -19,11 +19,12 @@
     <p:sldId id="264" r:id="rId10"/>
     <p:sldId id="265" r:id="rId11"/>
     <p:sldId id="266" r:id="rId12"/>
-    <p:sldId id="270" r:id="rId21"/>
-    <p:sldId id="267" r:id="rId13"/>
-    <p:sldId id="268" r:id="rId14"/>
-    <p:sldId id="269" r:id="rId15"/>
-    <p:sldId id="271" r:id="rId22"/>
+    <p:sldId id="270" r:id="rId13"/>
+    <p:sldId id="267" r:id="rId14"/>
+    <p:sldId id="268" r:id="rId15"/>
+    <p:sldId id="272" r:id="rId23"/>
+    <p:sldId id="269" r:id="rId16"/>
+    <p:sldId id="271" r:id="rId17"/>
   </p:sldIdLst>
   <p:sldSz cx="9144000" cy="5143500" type="screen16x9"/>
   <p:notesSz cx="5143500" cy="9144000"/>
@@ -147,6 +148,7 @@
         <p14:section name="Integration and evidence" id="{D4777D8D-F31C-CE19-0319-C8CC6A969C63}">
           <p14:sldIdLst>
             <p14:sldId id="266"/>
+            <p14:sldId id="270"/>
             <p14:sldId id="267"/>
           </p14:sldIdLst>
         </p14:section>
@@ -154,6 +156,7 @@
           <p14:sldIdLst>
             <p14:sldId id="268"/>
             <p14:sldId id="269"/>
+            <p14:sldId id="271"/>
           </p14:sldIdLst>
         </p14:section>
       </p14:sectionLst>
@@ -577,6 +580,30 @@
           <a:lstStyle/>
           <a:p>
             <a:r>
+              <a:rPr lang="en-US" b="1" dirty="0"/>
+              <a:t>SAY (~15 s):</a:t>
+            </a:r>
+          </a:p>
+          <a:p>
+            <a:r>
+              <a:rPr lang="en-US" dirty="0"/>
+              <a:t>- SwarmSentinel: a security checkpoint for AI agent swarms.</a:t>
+            </a:r>
+          </a:p>
+          <a:p>
+            <a:r>
+              <a:rPr lang="en-US" dirty="0"/>
+              <a:t>- Built on my ASP preprint; the QR code links to it.</a:t>
+            </a:r>
+          </a:p>
+          <a:p>
+            <a:r>
+              <a:rPr lang="en-US" b="1" dirty="0"/>
+              <a:t>Full notes:</a:t>
+            </a:r>
+          </a:p>
+          <a:p>
+            <a:r>
               <a:rPr lang="en-US" dirty="0"/>
               <a:t>SwarmSentinel is a runtime security layer for multi-agent systems. It sits between agents and their tools, decides every action before it runs, and watches the swarm as a whole for patterns no single agent's log would show. It implements the Agent Security Policy idea from my preprint, which you can scan from this slide: enforcement belongs in a layer the model cannot reach, and policy belongs in a format infrastructure can read. In the next few minutes: the threats, how the layer works, a live attack, and what it found on 1.2 million real agent actions.</a:t>
             </a:r>
@@ -664,6 +691,30 @@
           <a:lstStyle/>
           <a:p>
             <a:r>
+              <a:rPr lang="en-US" b="1" dirty="0"/>
+              <a:t>SAY (~15 s):</a:t>
+            </a:r>
+          </a:p>
+          <a:p>
+            <a:r>
+              <a:rPr lang="en-US" dirty="0"/>
+              <a:t>- No attacker needed.</a:t>
+            </a:r>
+          </a:p>
+          <a:p>
+            <a:r>
+              <a:rPr lang="en-US" dirty="0"/>
+              <a:t>- Loops get named and revoked; retry storms get throttled.</a:t>
+            </a:r>
+          </a:p>
+          <a:p>
+            <a:r>
+              <a:rPr lang="en-US" b="1" dirty="0"/>
+              <a:t>Full notes:</a:t>
+            </a:r>
+          </a:p>
+          <a:p>
+            <a:r>
               <a:rPr lang="en-US" dirty="0"/>
               <a:t>Not every swarm failure needs an attacker. Here a planner, an executor and a critic keep handing work around. The delegation-loop tripwire follows the hand-off chain and fires the moment work returns to an agent already on it, naming the loop: planner to executor to critic to planner. Separately, a scraper retries a fetch over and over. A per-agent step budget throttles it after twenty actions in ten seconds, and blocked attempts count too, so it stays throttled until it backs off. Note the graph: twenty repeated calls are one weighted edge, not twenty lines.</a:t>
             </a:r>
@@ -751,6 +802,24 @@
           <a:lstStyle/>
           <a:p>
             <a:r>
+              <a:rPr lang="en-US" b="1" dirty="0"/>
+              <a:t>SAY (~10 s):</a:t>
+            </a:r>
+          </a:p>
+          <a:p>
+            <a:r>
+              <a:rPr lang="en-US" dirty="0"/>
+              <a:t>- A few lines of Python. Under a millisecond per call.</a:t>
+            </a:r>
+          </a:p>
+          <a:p>
+            <a:r>
+              <a:rPr lang="en-US" b="1" dirty="0"/>
+              <a:t>Full notes:</a:t>
+            </a:r>
+          </a:p>
+          <a:p>
+            <a:r>
               <a:rPr lang="en-US" dirty="0"/>
               <a:t>Integration is a standard-library Python file. Wrap a tool with a decorator or call through the guard; a denied call raises instead of running, and an allowed one now reports whether it actually succeeded. The guard tracks which agent spawned which, and the gateway verifies it. Overhead: five thousand calls from twenty agents through full gateway and Sentinel checks, median 0.024 milliseconds in-process and 0.39 over localhost HTTP on an Apple M2. For tools you wrap yourself this is cooperative; the four demo tools run inside the engine, so there is nothing to bypass.</a:t>
             </a:r>
@@ -838,8 +907,32 @@
           <a:lstStyle/>
           <a:p>
             <a:r>
+              <a:rPr lang="en-US" b="1" dirty="0"/>
+              <a:t>SAY (~15 s):</a:t>
+            </a:r>
+          </a:p>
+          <a:p>
+            <a:r>
               <a:rPr lang="en-US" dirty="0"/>
-              <a:t>To test this beyond toy scenarios, we replayed the AI Village dataset from AI Digest: 389 days of 46 frontier-model agents working in a shared environment, 1.23 million actions. Historical actions already happened, so this runs in ASP's report-only mode: every number here is what the policy would have done, not harm prevented. The policy would have stopped about 7.9 percent of actions, mostly reads outside a deliberately strict network allowlist. More interesting: 4,681 direct reads of credential stores, and 44 percent of shared-state writes came from sessions that had already read untrusted web content. Dataset cited as AI Digest, AI Village dataset, 2026.</a:t>
+              <a:t>- Allowed is not done: tools report success or failure.</a:t>
+            </a:r>
+          </a:p>
+          <a:p>
+            <a:r>
+              <a:rPr lang="en-US" dirty="0"/>
+              <a:t>- Retries never pay twice.</a:t>
+            </a:r>
+          </a:p>
+          <a:p>
+            <a:r>
+              <a:rPr lang="en-US" b="1" dirty="0"/>
+              <a:t>Full notes:</a:t>
+            </a:r>
+          </a:p>
+          <a:p>
+            <a:r>
+              <a:rPr lang="en-US" dirty="0"/>
+              <a:t>The gateway answers before a tool runs, so allowed means permission, not that the work happened. Tools now send a completion receipt: succeeded or failed, with no results or secrets in it. The dashboard shows authorized calls and actual outcomes separately, so an investigator can tell a payment that was permitted from one that completed. Second, retries are safe. Every sandbox execution carries an idempotency key; if the network drops the reply, retrying with the same key returns the original outcome instead of paying twice. An optional journal lets a caller recover after its own process restarts. Sessions themselves still live in memory and are lost if the engine restarts.</a:t>
             </a:r>
           </a:p>
         </p:txBody>
@@ -925,8 +1018,32 @@
           <a:lstStyle/>
           <a:p>
             <a:r>
+              <a:rPr lang="en-US" b="1" dirty="0"/>
+              <a:t>SAY (~15 s):</a:t>
+            </a:r>
+          </a:p>
+          <a:p>
+            <a:r>
               <a:rPr lang="en-US" dirty="0"/>
-              <a:t>What this is not, yet. Tools you wrap with our guard are cooperative: an agent that calls them directly is not stopped. Only the four engine-owned demo tools are truly behind the gateway. There is no container or operating-system isolation, and sessions live in memory, so an engine restart loses them. In the real-agent runs the models are instructed to probe the guard, so those runs prove the guard holds, not that a model was fooled spontaneously. Thresholds were tuned on one dataset. The roadmap answers each: an MCP proxy so every tool sits behind the gateway, process or container isolation, durable sessions, taint through shared files, and server-assigned policies beyond the demo.</a:t>
+              <a:t>- We replayed 1.23 million real agent actions.</a:t>
+            </a:r>
+          </a:p>
+          <a:p>
+            <a:r>
+              <a:rPr lang="en-US" dirty="0"/>
+              <a:t>- The policy would have blocked 7.9%, including 4,681 credential reads. All counterfactual.</a:t>
+            </a:r>
+          </a:p>
+          <a:p>
+            <a:r>
+              <a:rPr lang="en-US" b="1" dirty="0"/>
+              <a:t>Full notes:</a:t>
+            </a:r>
+          </a:p>
+          <a:p>
+            <a:r>
+              <a:rPr lang="en-US" dirty="0"/>
+              <a:t>To test this beyond toy scenarios, we replayed the AI Village dataset from AI Digest: 389 days of 46 frontier-model agents working in a shared environment, 1.23 million actions. Historical actions already happened, so this runs in ASP's report-only mode: every number here is what the policy would have done, not harm prevented. The policy would have stopped about 7.9 percent of actions, mostly reads outside a deliberately strict network allowlist. More interesting: 4,681 direct reads of credential stores, and 44 percent of shared-state writes came from sessions that had already read untrusted web content. Dataset cited as AI Digest, AI Village dataset, 2026.</a:t>
             </a:r>
           </a:p>
         </p:txBody>
@@ -1012,8 +1129,32 @@
           <a:lstStyle/>
           <a:p>
             <a:r>
+              <a:rPr lang="en-US" b="1" dirty="0"/>
+              <a:t>SAY (~15 s):</a:t>
+            </a:r>
+          </a:p>
+          <a:p>
+            <a:r>
               <a:rPr lang="en-US" dirty="0"/>
-              <a:t>Thank you. The QR code links to the ASP preprint on SSRN, which lays out the reasoning behind this work: why enforcement has to sit outside the model, and why policy should be machine-readable. The code, the threat model and the live demo are all public. The real-data evaluation uses the AI Village dataset from AI Digest, which we access under their research terms. Happy to take questions, especially the hard ones about what this does not cover yet.</a:t>
+              <a:t>- Not yet: OS isolation, and wrapped tools can be bypassed.</a:t>
+            </a:r>
+          </a:p>
+          <a:p>
+            <a:r>
+              <a:rPr lang="en-US" dirty="0"/>
+              <a:t>- Next: an MCP proxy in front of every tool.</a:t>
+            </a:r>
+          </a:p>
+          <a:p>
+            <a:r>
+              <a:rPr lang="en-US" b="1" dirty="0"/>
+              <a:t>Full notes:</a:t>
+            </a:r>
+          </a:p>
+          <a:p>
+            <a:r>
+              <a:rPr lang="en-US" dirty="0"/>
+              <a:t>What this is not, yet. Tools you wrap with our guard are cooperative: an agent that calls them directly is not stopped. Only the four engine-owned demo tools are truly behind the gateway. There is no container or operating-system isolation, and sessions live in memory, so an engine restart loses them. In the real-agent runs the models are instructed to probe the guard, so those runs prove the guard holds, not that a model was fooled spontaneously. Thresholds were tuned on one dataset. The roadmap answers each: an MCP proxy so every tool sits behind the gateway, process or container isolation, durable sessions, taint through shared files, and server-assigned policies beyond the demo.</a:t>
             </a:r>
           </a:p>
         </p:txBody>
@@ -1099,8 +1240,26 @@
           <a:lstStyle/>
           <a:p>
             <a:r>
+              <a:rPr lang="en-US" b="1" dirty="0"/>
+              <a:t>SAY (~10 s):</a:t>
+            </a:r>
+          </a:p>
+          <a:p>
+            <a:r>
               <a:rPr lang="en-US" dirty="0"/>
-              <a:t>The gateway answers before a tool runs, so allowed means permission, not that the work happened. Tools now send a completion receipt: succeeded or failed, with no results or secrets in it. The dashboard shows authorized calls and actual outcomes separately, so an investigator can tell a payment that was permitted from one that completed. Second, retries are safe. Every sandbox execution carries an idempotency key; if the network drops the reply, retrying with the same key returns the original outcome instead of paying twice. An optional journal lets a caller recover after its own process restarts. Sessions themselves still live in memory and are lost if the engine restarts.</a:t>
+              <a:t>- Paper, code and demo are all linked here. Thank you.</a:t>
+            </a:r>
+          </a:p>
+          <a:p>
+            <a:r>
+              <a:rPr lang="en-US" b="1" dirty="0"/>
+              <a:t>Full notes:</a:t>
+            </a:r>
+          </a:p>
+          <a:p>
+            <a:r>
+              <a:rPr lang="en-US" dirty="0"/>
+              <a:t>Thank you. The QR code links to the ASP preprint on SSRN, which lays out the reasoning behind this work: why enforcement has to sit outside the model, and why policy should be machine-readable. The code, the threat model and the live demo are all public. The real-data evaluation uses the AI Village dataset from AI Digest, which we access under their research terms. Happy to take questions, especially the hard ones about what this does not cover yet.</a:t>
             </a:r>
           </a:p>
         </p:txBody>
@@ -1122,7 +1281,7 @@
           <a:p>
             <a:fld id="{F7021451-1387-4CA6-816F-3879F97B5CBC}" type="slidenum">
               <a:rPr lang="en-US"/>
-              <a:t>11</a:t>
+              <a:t>15</a:t>
             </a:fld>
             <a:endParaRPr lang="en-US"/>
           </a:p>
@@ -1186,6 +1345,24 @@
           <a:lstStyle/>
           <a:p>
             <a:r>
+              <a:rPr lang="en-US" b="1" dirty="0"/>
+              <a:t>SAY (~10 s):</a:t>
+            </a:r>
+          </a:p>
+          <a:p>
+            <a:r>
+              <a:rPr lang="en-US" dirty="0"/>
+              <a:t>- Skip in the recording; appendix for judges.</a:t>
+            </a:r>
+          </a:p>
+          <a:p>
+            <a:r>
+              <a:rPr lang="en-US" b="1" dirty="0"/>
+              <a:t>Full notes:</a:t>
+            </a:r>
+          </a:p>
+          <a:p>
+            <a:r>
               <a:rPr lang="en-US" dirty="0"/>
               <a:t>Appendix for judges; hidden during the talk. The AI Village data cannot be redistributed, so judges with their own approved Hugging Face access can rebuild the same local SQLite store: download seven tables, run village.ingest and village.scan, about ten minutes on a laptop. Then python -m village.replay lists the ranked episodes and replays one, writing the same report and trace the dashboard exports, with no sign-in. The dashboard path needs a free Clerk development app. Full steps are in docs/JUDGES.md.</a:t>
             </a:r>
@@ -1209,7 +1386,118 @@
           <a:p>
             <a:fld id="{F7021451-1387-4CA6-816F-3879F97B5CBC}" type="slidenum">
               <a:rPr lang="en-US"/>
-              <a:t>13</a:t>
+              <a:t>16</a:t>
+            </a:fld>
+            <a:endParaRPr lang="en-US"/>
+          </a:p>
+        </p:txBody>
+      </p:sp>
+    </p:spTree>
+    <p:extLst>
+      <p:ext uri="{BB962C8B-B14F-4D97-AF65-F5344CB8AC3E}">
+        <p14:creationId xmlns:p14="http://schemas.microsoft.com/office/powerpoint/2010/main" val="1024086991"/>
+      </p:ext>
+    </p:extLst>
+  </p:cSld>
+  <p:clrMapOvr>
+    <a:masterClrMapping/>
+  </p:clrMapOvr>
+</p:notes>
+</file>
+
+<file path=ppt/notesSlides/notesSlide17.xml><?xml version="1.0" encoding="utf-8"?>
+<p:notes xmlns:a="http://schemas.openxmlformats.org/drawingml/2006/main" xmlns:r="http://schemas.openxmlformats.org/officeDocument/2006/relationships" xmlns:p="http://schemas.openxmlformats.org/presentationml/2006/main">
+  <p:cSld>
+    <p:spTree>
+      <p:nvGrpSpPr>
+        <p:cNvPr id="1" name=""/>
+        <p:cNvGrpSpPr/>
+        <p:nvPr/>
+      </p:nvGrpSpPr>
+      <p:grpSpPr>
+        <a:xfrm>
+          <a:off x="0" y="0"/>
+          <a:ext cx="0" cy="0"/>
+          <a:chOff x="0" y="0"/>
+          <a:chExt cx="0" cy="0"/>
+        </a:xfrm>
+      </p:grpSpPr>
+      <p:sp>
+        <p:nvSpPr>
+          <p:cNvPr id="2" name="Slide Image Placeholder 1"/>
+          <p:cNvSpPr>
+            <a:spLocks noGrp="1" noRot="1" noChangeAspect="1"/>
+          </p:cNvSpPr>
+          <p:nvPr>
+            <p:ph type="sldImg"/>
+          </p:nvPr>
+        </p:nvSpPr>
+        <p:spPr/>
+      </p:sp>
+      <p:sp>
+        <p:nvSpPr>
+          <p:cNvPr id="3" name="Notes Placeholder 2"/>
+          <p:cNvSpPr>
+            <a:spLocks noGrp="1"/>
+          </p:cNvSpPr>
+          <p:nvPr>
+            <p:ph type="body" idx="1"/>
+          </p:nvPr>
+        </p:nvSpPr>
+        <p:spPr/>
+        <p:txBody>
+          <a:bodyPr/>
+          <a:lstStyle/>
+          <a:p>
+            <a:r>
+              <a:rPr lang="en-US" b="1" dirty="0"/>
+              <a:t>SAY (~15 s):</a:t>
+            </a:r>
+          </a:p>
+          <a:p>
+            <a:r>
+              <a:rPr lang="en-US" dirty="0"/>
+              <a:t>- Try it at swarmsentinel.replit.app.</a:t>
+            </a:r>
+          </a:p>
+          <a:p>
+            <a:r>
+              <a:rPr lang="en-US" dirty="0"/>
+              <a:t>- Each tab is one story from this talk; AI Village opens for approved accounts only.</a:t>
+            </a:r>
+          </a:p>
+          <a:p>
+            <a:r>
+              <a:rPr lang="en-US" b="1" dirty="0"/>
+              <a:t>Full notes:</a:t>
+            </a:r>
+          </a:p>
+          <a:p>
+            <a:r>
+              <a:rPr lang="en-US" dirty="0"/>
+              <a:t>The deployed app has six tabs on one engine. Normal Run is the clean baseline: three agents with distinct tasks and no alerts. Swarm Attack shows delegation chains, echoed answers and fan-out tripping the Sentinel, which revokes the branches. Prompt Injection is the poisoned-invoice attack from the paper: the $5,000 transfer is stopped by scope and taint. Runaway Loop has no attacker: a plan-execute-critique cycle that never converges and a scraper retrying 22 times, named and throttled. AI Village replays real dataset episodes in report-only mode, so results are counterfactual; it is dimmed unless the signed-in account is an approved reader, and judges can rebuild it locally with docs/JUDGES.md. Live connects real agents to engine-owned tools and streams each decision as it happens.</a:t>
+            </a:r>
+          </a:p>
+        </p:txBody>
+      </p:sp>
+      <p:sp>
+        <p:nvSpPr>
+          <p:cNvPr id="4" name="Slide Number Placeholder 3"/>
+          <p:cNvSpPr>
+            <a:spLocks noGrp="1"/>
+          </p:cNvSpPr>
+          <p:nvPr>
+            <p:ph type="sldNum" sz="quarter" idx="10"/>
+          </p:nvPr>
+        </p:nvSpPr>
+        <p:spPr/>
+        <p:txBody>
+          <a:bodyPr/>
+          <a:lstStyle/>
+          <a:p>
+            <a:fld id="{F7021451-1387-4CA6-816F-3879F97B5CBC}" type="slidenum">
+              <a:rPr lang="en-US"/>
+              <a:t>14</a:t>
             </a:fld>
             <a:endParaRPr lang="en-US"/>
           </a:p>
@@ -1273,6 +1561,30 @@
           <a:lstStyle/>
           <a:p>
             <a:r>
+              <a:rPr lang="en-US" b="1" dirty="0"/>
+              <a:t>SAY (~15 s):</a:t>
+            </a:r>
+          </a:p>
+          <a:p>
+            <a:r>
+              <a:rPr lang="en-US" dirty="0"/>
+              <a:t>- Swarms fail as a system: injections spread, tools get misused, loops never stop.</a:t>
+            </a:r>
+          </a:p>
+          <a:p>
+            <a:r>
+              <a:rPr lang="en-US" dirty="0"/>
+              <a:t>- No single agent's log shows it.</a:t>
+            </a:r>
+          </a:p>
+          <a:p>
+            <a:r>
+              <a:rPr lang="en-US" b="1" dirty="0"/>
+              <a:t>Full notes:</a:t>
+            </a:r>
+          </a:p>
+          <a:p>
+            <a:r>
               <a:rPr lang="en-US" dirty="0"/>
               <a:t>Four failure modes. One: a single agent reads a poisoned document, and the instruction travels through the swarm in ordinary messages. Two: agents hold far more tool access than the task needs, so one bad instruction can reach payments or credentials. Three: with no attacker at all, agents hand work around in circles or retry forever. Four: each agent's own log looks reasonable; the problem is only visible across the swarm. Prompt hardening alone cannot fix these, because the model evaluating the attack is the one being attacked.</a:t>
             </a:r>
@@ -1360,6 +1672,30 @@
           <a:lstStyle/>
           <a:p>
             <a:r>
+              <a:rPr lang="en-US" b="1" dirty="0"/>
+              <a:t>SAY (~15 s):</a:t>
+            </a:r>
+          </a:p>
+          <a:p>
+            <a:r>
+              <a:rPr lang="en-US" dirty="0"/>
+              <a:t>- The model can be fooled, so the check moves outside it.</a:t>
+            </a:r>
+          </a:p>
+          <a:p>
+            <a:r>
+              <a:rPr lang="en-US" dirty="0"/>
+              <a:t>- Every tool call stops at a gateway that reads a policy file.</a:t>
+            </a:r>
+          </a:p>
+          <a:p>
+            <a:r>
+              <a:rPr lang="en-US" b="1" dirty="0"/>
+              <a:t>Full notes:</a:t>
+            </a:r>
+          </a:p>
+          <a:p>
+            <a:r>
               <a:rPr lang="en-US" dirty="0"/>
               <a:t>This is the one idea behind everything else. An AI agent reads things: your instructions, and also web pages, documents and tool output. All of it lands in the same context window, and the model has no reliable way to tell your rules apart from an attacker's text. So asking the model to police itself does not work. ASP moves the check outside the model. Every time the agent tries to use a tool, the call stops at a gateway that consults a policy file, not the conversation. If the policy allows it, the call goes through; if not, it never runs, and either way it is logged. It is the same move browsers made with Content Security Policy. SwarmSentinel implements this gateway. Honestly, against the figure: decisions are verifiable and logged; sessions are authenticated; and for the four demo tools the engine owns the tool bodies, so every call has to pass the gateway. It is not yet tamper-proof in the paper's sense: it runs on the same host with no container or operating-system isolation, and generic tools wrapped by our guard are still cooperative. That is row T8 on the next slide.</a:t>
             </a:r>
@@ -1447,6 +1783,30 @@
           <a:lstStyle/>
           <a:p>
             <a:r>
+              <a:rPr lang="en-US" b="1" dirty="0"/>
+              <a:t>SAY (~15 s):</a:t>
+            </a:r>
+          </a:p>
+          <a:p>
+            <a:r>
+              <a:rPr lang="en-US" dirty="0"/>
+              <a:t>- Eight threats: five enforced today.</a:t>
+            </a:r>
+          </a:p>
+          <a:p>
+            <a:r>
+              <a:rPr lang="en-US" dirty="0"/>
+              <a:t>- We mark the rest honestly as report-only, observe-only or partial.</a:t>
+            </a:r>
+          </a:p>
+          <a:p>
+            <a:r>
+              <a:rPr lang="en-US" b="1" dirty="0"/>
+              <a:t>Full notes:</a:t>
+            </a:r>
+          </a:p>
+          <a:p>
+            <a:r>
               <a:rPr lang="en-US" dirty="0"/>
               <a:t>Here is the threat model. Each row is a threat vector, the rules that address it, and a status. Enforced means the call is blocked before it executes, in our scenarios and in live sessions. Credential exposure is report-only because we measured it on real historical data. Activity outside the gateway can only be observed, and we say so. Tampering with the gateway is partial: sessions are authenticated and owner-only, and the demo tools execute inside the engine only after the gateway allows them, so for those tools there is nothing to bypass. But there is no operating-system isolation, and tools wrapped by our generic guard still rely on the agent calling through it. The full document lists the evidence for every row and six known gaps. I would rather show you the edges than claim coverage we do not have.</a:t>
             </a:r>
@@ -1534,6 +1894,30 @@
           <a:lstStyle/>
           <a:p>
             <a:r>
+              <a:rPr lang="en-US" b="1" dirty="0"/>
+              <a:t>SAY (~15 s):</a:t>
+            </a:r>
+          </a:p>
+          <a:p>
+            <a:r>
+              <a:rPr lang="en-US" dirty="0"/>
+              <a:t>- The agent asks, the gateway decides, the Sentinel watches the whole swarm.</a:t>
+            </a:r>
+          </a:p>
+          <a:p>
+            <a:r>
+              <a:rPr lang="en-US" dirty="0"/>
+              <a:t>- Compromised branches get revoked.</a:t>
+            </a:r>
+          </a:p>
+          <a:p>
+            <a:r>
+              <a:rPr lang="en-US" b="1" dirty="0"/>
+              <a:t>Full notes:</a:t>
+            </a:r>
+          </a:p>
+          <a:p>
+            <a:r>
               <a:rPr lang="en-US" dirty="0"/>
               <a:t>The agent's code calls tools through a small guard. Before anything runs, the guard sends the proposed action to the ASP gateway. The gateway evaluates it against a declared policy file, not against the model's reasoning, and answers allow or deny with the rule that decided. Allowed actions feed the Sentinel, which keeps a weighted graph of who did what with whom and watches for swarm-level patterns. When a tripwire fires, it feeds a revocation back to the gateway, so the next call from a compromised agent is refused. Everything is recorded and streamed live.</a:t>
             </a:r>
@@ -1621,6 +2005,30 @@
           <a:lstStyle/>
           <a:p>
             <a:r>
+              <a:rPr lang="en-US" b="1" dirty="0"/>
+              <a:t>SAY (~15 s):</a:t>
+            </a:r>
+          </a:p>
+          <a:p>
+            <a:r>
+              <a:rPr lang="en-US" dirty="0"/>
+              <a:t>- Policy is a JSON file, not a prompt.</a:t>
+            </a:r>
+          </a:p>
+          <a:p>
+            <a:r>
+              <a:rPr lang="en-US" dirty="0"/>
+              <a:t>- Nine checks in a fixed order.</a:t>
+            </a:r>
+          </a:p>
+          <a:p>
+            <a:r>
+              <a:rPr lang="en-US" b="1" dirty="0"/>
+              <a:t>Full notes:</a:t>
+            </a:r>
+          </a:p>
+          <a:p>
+            <a:r>
               <a:rPr lang="en-US" dirty="0"/>
               <a:t>Policy is a JSON file following the schema in the ASP paper, with a swarm extension. On the right is the order the gateway evaluates a call: identity and lineage first, then whether the agent was revoked or has exhausted its step budget, then the explicit deny list before the default-deny allowlist, then the scope this agent was delegated, argument and network rules, whether its context is tainted by untrusted content, and finally rate limits. Same file format for the live gateway and for replaying historical data.</a:t>
             </a:r>
@@ -1708,6 +2116,30 @@
           <a:lstStyle/>
           <a:p>
             <a:r>
+              <a:rPr lang="en-US" b="1" dirty="0"/>
+              <a:t>SAY (~15 s):</a:t>
+            </a:r>
+          </a:p>
+          <a:p>
+            <a:r>
+              <a:rPr lang="en-US" dirty="0"/>
+              <a:t>- A poisoned invoice tries to move $5,000.</a:t>
+            </a:r>
+          </a:p>
+          <a:p>
+            <a:r>
+              <a:rPr lang="en-US" dirty="0"/>
+              <a:t>- Each layer stops one step. Zero dollars move.</a:t>
+            </a:r>
+          </a:p>
+          <a:p>
+            <a:r>
+              <a:rPr lang="en-US" b="1" dirty="0"/>
+              <a:t>Full notes:</a:t>
+            </a:r>
+          </a:p>
+          <a:p>
+            <a:r>
               <a:rPr lang="en-US" dirty="0"/>
               <a:t>This is the attack from my paper. An orchestrator delegates invoice parsing to a sub-agent that may only read files. The invoice contains an instruction to transfer five thousand dollars. In this scripted version the agents obey it, standing in for a model that has been successfully injected. A second version runs the same story with real gpt-5.4-mini agents on engine-owned sandbox files; there the models are explicitly told to stress-test the guard, so a block shows the guard working, not that the model fell for the injection on its own. Watch the layers: the parser's own payment call is out of its delegated scope; its attempt to spawn a helper with payment rights is refused; it then relays the instruction to the ledger agent, which really does hold payment rights. That is the interesting step, on the next slide. The tripwire then revokes the compromised branch, and the clean orchestrator keeps working. Not one dollar moved.</a:t>
             </a:r>
@@ -1795,6 +2227,30 @@
           <a:lstStyle/>
           <a:p>
             <a:r>
+              <a:rPr lang="en-US" b="1" dirty="0"/>
+              <a:t>SAY (~15 s):</a:t>
+            </a:r>
+          </a:p>
+          <a:p>
+            <a:r>
+              <a:rPr lang="en-US" dirty="0"/>
+              <a:t>- The ledger agent is allowed to pay, yet it is blocked.</a:t>
+            </a:r>
+          </a:p>
+          <a:p>
+            <a:r>
+              <a:rPr lang="en-US" dirty="0"/>
+              <a:t>- The taint travels with the message: scope alone would have paid.</a:t>
+            </a:r>
+          </a:p>
+          <a:p>
+            <a:r>
+              <a:rPr lang="en-US" b="1" dirty="0"/>
+              <a:t>Full notes:</a:t>
+            </a:r>
+          </a:p>
+          <a:p>
+            <a:r>
               <a:rPr lang="en-US" dirty="0"/>
               <a:t>This is the moment I want you to remember. The ledger agent is allowed to make payments; that is its job. Least-privilege scoping alone would have let this payment through, because the instruction arrived as a normal message from a colleague. SwarmSentinel tracks where information came from. The parser read untrusted content, so its messages carry that taint, and the ledger agent inherits it. A tainted context loses the dangerous capabilities named in policy, regardless of scope. And every decision records the origin event, so an investigator can trace exactly where the contamination started.</a:t>
             </a:r>
@@ -1880,6 +2336,24 @@
         <p:txBody>
           <a:bodyPr/>
           <a:lstStyle/>
+          <a:p>
+            <a:r>
+              <a:rPr lang="en-US" b="1" dirty="0"/>
+              <a:t>SAY (~10 s):</a:t>
+            </a:r>
+          </a:p>
+          <a:p>
+            <a:r>
+              <a:rPr lang="en-US" dirty="0"/>
+              <a:t>- This runs live: every decision streams in as it happens.</a:t>
+            </a:r>
+          </a:p>
+          <a:p>
+            <a:r>
+              <a:rPr lang="en-US" b="1" dirty="0"/>
+              <a:t>Full notes:</a:t>
+            </a:r>
+          </a:p>
           <a:p>
             <a:r>
               <a:rPr lang="en-US" dirty="0"/>
@@ -2733,7 +3207,7 @@
                 <a:ea typeface="JetBrains Mono" pitchFamily="34" charset="-122"/>
                 <a:cs typeface="JetBrains Mono" pitchFamily="34" charset="-120"/>
               </a:rPr>
-              <a:t>01 / 15</a:t>
+              <a:t>01 / 16</a:t>
             </a:r>
             <a:endParaRPr lang="en-US" sz="1130" dirty="0"/>
           </a:p>
@@ -2903,7 +3377,7 @@
         <p:spPr>
           <a:xfrm>
             <a:off x="566928" y="4389120"/>
-            <a:ext cx="6309360" cy="274320"/>
+            <a:ext cx="6309360" cy="475488"/>
           </a:xfrm>
           <a:prstGeom prst="rect">
             <a:avLst/>
@@ -2936,6 +3410,22 @@
               </a:rPr>
               <a:t>ASP preprint  ·  doi.org/10.2139/ssrn.6876926</a:t>
             </a:r>
+            <a:endParaRPr lang="en-US" sz="1130" u="sng" dirty="0">
+              <a:solidFill>
+                <a:schemeClr val="tx2"/>
+              </a:solidFill>
+              <a:latin typeface="JetBrains Mono" pitchFamily="34" charset="0"/>
+              <a:ea typeface="JetBrains Mono" pitchFamily="34" charset="-122"/>
+              <a:cs typeface="JetBrains Mono" pitchFamily="34" charset="-120"/>
+            </a:endParaRPr>
+          </a:p>
+          <a:p>
+            <a:r>
+              <a:rPr lang="en-US" sz="1130" dirty="0">
+                <a:hlinkClick r:id="rId4"/>
+              </a:rPr>
+              <a:t>https://www.linkedin.com/in/prasad-m-k</a:t>
+            </a:r>
             <a:endParaRPr lang="en-US" sz="1130" dirty="0"/>
           </a:p>
         </p:txBody>
@@ -2949,7 +3439,7 @@
           <p:nvPr/>
         </p:nvPicPr>
         <p:blipFill>
-          <a:blip r:embed="rId4"/>
+          <a:blip r:embed="rId5"/>
           <a:stretch>
             <a:fillRect/>
           </a:stretch>
@@ -3094,7 +3584,7 @@
                 <a:ea typeface="JetBrains Mono" pitchFamily="34" charset="-122"/>
                 <a:cs typeface="JetBrains Mono" pitchFamily="34" charset="-120"/>
               </a:rPr>
-              <a:t>10 / 15</a:t>
+              <a:t>10 / 16</a:t>
             </a:r>
             <a:endParaRPr lang="en-US" sz="1130" dirty="0"/>
           </a:p>
@@ -3364,7 +3854,7 @@
                 <a:ea typeface="JetBrains Mono" pitchFamily="34" charset="-122"/>
                 <a:cs typeface="JetBrains Mono" pitchFamily="34" charset="-120"/>
               </a:rPr>
-              <a:t>11 / 15</a:t>
+              <a:t>11 / 16</a:t>
             </a:r>
             <a:endParaRPr lang="en-US" sz="1130" dirty="0"/>
           </a:p>
@@ -3899,6 +4389,595 @@
 </file>
 
 <file path=ppt/slides/slide12.xml><?xml version="1.0" encoding="utf-8"?>
+<p:sld xmlns:a="http://schemas.openxmlformats.org/drawingml/2006/main" xmlns:r="http://schemas.openxmlformats.org/officeDocument/2006/relationships" xmlns:p="http://schemas.openxmlformats.org/presentationml/2006/main">
+  <p:cSld name="Slide 11">
+    <p:spTree>
+      <p:nvGrpSpPr>
+        <p:cNvPr id="1" name=""/>
+        <p:cNvGrpSpPr/>
+        <p:nvPr/>
+      </p:nvGrpSpPr>
+      <p:grpSpPr>
+        <a:xfrm>
+          <a:off x="0" y="0"/>
+          <a:ext cx="0" cy="0"/>
+          <a:chOff x="0" y="0"/>
+          <a:chExt cx="0" cy="0"/>
+        </a:xfrm>
+      </p:grpSpPr>
+      <p:sp>
+        <p:nvSpPr>
+          <p:cNvPr id="2" name="Page number"/>
+          <p:cNvSpPr txBox="1"/>
+          <p:nvPr/>
+        </p:nvSpPr>
+        <p:spPr>
+          <a:xfrm>
+            <a:off x="7653528" y="4864608"/>
+            <a:ext cx="914400" cy="219456"/>
+          </a:xfrm>
+          <a:prstGeom prst="rect">
+            <a:avLst/>
+          </a:prstGeom>
+          <a:noFill/>
+          <a:ln/>
+        </p:spPr>
+        <p:txBody>
+          <a:bodyPr wrap="square" lIns="0" tIns="0" rIns="0" bIns="0" rtlCol="0" anchor="ctr"/>
+          <a:lstStyle/>
+          <a:p>
+            <a:pPr marL="0" indent="0" algn="r">
+              <a:buNone/>
+            </a:pPr>
+            <a:r>
+              <a:rPr lang="en-US" sz="1130" dirty="0">
+                <a:solidFill>
+                  <a:schemeClr val="tx2"/>
+                </a:solidFill>
+                <a:latin typeface="JetBrains Mono" pitchFamily="34" charset="0"/>
+                <a:ea typeface="JetBrains Mono" pitchFamily="34" charset="-122"/>
+                <a:cs typeface="JetBrains Mono" pitchFamily="34" charset="-120"/>
+              </a:rPr>
+              <a:t>12 / 16</a:t>
+            </a:r>
+            <a:endParaRPr lang="en-US" sz="1130" dirty="0"/>
+          </a:p>
+        </p:txBody>
+      </p:sp>
+      <p:sp>
+        <p:nvSpPr>
+          <p:cNvPr id="3" name="Text 3"/>
+          <p:cNvSpPr>
+            <a:spLocks noGrp="1"/>
+          </p:cNvSpPr>
+          <p:nvPr>
+            <p:ph type="title" idx="103" hasCustomPrompt="1"/>
+          </p:nvPr>
+        </p:nvSpPr>
+        <p:spPr>
+          <a:xfrm>
+            <a:off x="566928" y="566928"/>
+            <a:ext cx="8001000" cy="512064"/>
+          </a:xfrm>
+          <a:prstGeom prst="rect">
+            <a:avLst/>
+          </a:prstGeom>
+          <a:noFill/>
+          <a:ln/>
+        </p:spPr>
+        <p:txBody>
+          <a:bodyPr wrap="square" lIns="0" tIns="0" rIns="0" bIns="0" rtlCol="0" anchor="ctr"/>
+          <a:lstStyle/>
+          <a:p>
+            <a:pPr marL="0" indent="0" algn="l">
+              <a:buNone/>
+            </a:pPr>
+            <a:r>
+              <a:rPr lang="en-US" sz="2850" b="1" dirty="0">
+                <a:solidFill>
+                  <a:schemeClr val="tx1"/>
+                </a:solidFill>
+              </a:rPr>
+              <a:t>Allowed is not done: receipts and safe retries</a:t>
+            </a:r>
+            <a:endParaRPr lang="en-US" sz="2850" dirty="0"/>
+          </a:p>
+        </p:txBody>
+      </p:sp>
+      <p:sp>
+        <p:nvSpPr>
+          <p:cNvPr id="4" name="Receipt code"/>
+          <p:cNvSpPr/>
+          <p:nvPr/>
+        </p:nvSpPr>
+        <p:spPr>
+          <a:xfrm>
+            <a:off x="566928" y="1325880"/>
+            <a:ext cx="4846320" cy="3246120"/>
+          </a:xfrm>
+          <a:prstGeom prst="rect">
+            <a:avLst/>
+          </a:prstGeom>
+          <a:solidFill>
+            <a:schemeClr val="bg2"/>
+          </a:solidFill>
+          <a:ln/>
+        </p:spPr>
+        <p:txBody>
+          <a:bodyPr/>
+          <a:lstStyle/>
+          <a:p>
+            <a:endParaRPr lang="en-US"/>
+          </a:p>
+        </p:txBody>
+      </p:sp>
+      <p:sp>
+        <p:nvSpPr>
+          <p:cNvPr id="5" name="Guard snippet"/>
+          <p:cNvSpPr txBox="1"/>
+          <p:nvPr/>
+        </p:nvSpPr>
+        <p:spPr>
+          <a:xfrm>
+            <a:off x="731520" y="1463040"/>
+            <a:ext cx="4572000" cy="2971800"/>
+          </a:xfrm>
+          <a:prstGeom prst="rect">
+            <a:avLst/>
+          </a:prstGeom>
+          <a:noFill/>
+          <a:ln/>
+        </p:spPr>
+        <p:txBody>
+          <a:bodyPr wrap="square" lIns="0" tIns="0" rIns="0" bIns="0" rtlCol="0" anchor="ctr"/>
+          <a:lstStyle/>
+          <a:p>
+            <a:pPr marL="0" indent="0">
+              <a:buNone/>
+            </a:pPr>
+            <a:r>
+              <a:rPr lang="en-US" sz="1050" dirty="0">
+                <a:solidFill>
+                  <a:schemeClr val="tx1"/>
+                </a:solidFill>
+                <a:latin typeface="JetBrains Mono" pitchFamily="34" charset="0"/>
+                <a:ea typeface="JetBrains Mono" pitchFamily="34" charset="-122"/>
+                <a:cs typeface="JetBrains Mono" pitchFamily="34" charset="-120"/>
+              </a:rPr>
+              <a:t>decision = agent.check("tool", "mock:fs.read")</a:t>
+            </a:r>
+            <a:endParaRPr lang="en-US" sz="1050" dirty="0"/>
+          </a:p>
+          <a:p>
+            <a:pPr marL="0" indent="0">
+              <a:buNone/>
+            </a:pPr>
+            <a:r>
+              <a:rPr lang="en-US" sz="1050" dirty="0">
+                <a:solidFill>
+                  <a:schemeClr val="tx1"/>
+                </a:solidFill>
+                <a:latin typeface="JetBrains Mono" pitchFamily="34" charset="0"/>
+                <a:ea typeface="JetBrains Mono" pitchFamily="34" charset="-122"/>
+                <a:cs typeface="JetBrains Mono" pitchFamily="34" charset="-120"/>
+              </a:rPr>
+              <a:t>if not decision.allowed:</a:t>
+            </a:r>
+            <a:endParaRPr lang="en-US" sz="1050" dirty="0"/>
+          </a:p>
+          <a:p>
+            <a:pPr marL="0" indent="0">
+              <a:buNone/>
+            </a:pPr>
+            <a:r>
+              <a:rPr lang="en-US" sz="1050" dirty="0">
+                <a:solidFill>
+                  <a:schemeClr val="tx1"/>
+                </a:solidFill>
+                <a:latin typeface="JetBrains Mono" pitchFamily="34" charset="0"/>
+                <a:ea typeface="JetBrains Mono" pitchFamily="34" charset="-122"/>
+                <a:cs typeface="JetBrains Mono" pitchFamily="34" charset="-120"/>
+              </a:rPr>
+              <a:t>    raise PolicyViolation(decision)</a:t>
+            </a:r>
+            <a:endParaRPr lang="en-US" sz="1050" dirty="0"/>
+          </a:p>
+          <a:p>
+            <a:pPr marL="0" indent="0">
+              <a:buNone/>
+            </a:pPr>
+            <a:r>
+              <a:rPr lang="en-US" sz="1050" dirty="0">
+                <a:solidFill>
+                  <a:schemeClr val="tx1"/>
+                </a:solidFill>
+                <a:latin typeface="JetBrains Mono" pitchFamily="34" charset="0"/>
+                <a:ea typeface="JetBrains Mono" pitchFamily="34" charset="-122"/>
+                <a:cs typeface="JetBrains Mono" pitchFamily="34" charset="-120"/>
+              </a:rPr>
+              <a:t>try:</a:t>
+            </a:r>
+            <a:endParaRPr lang="en-US" sz="1050" dirty="0"/>
+          </a:p>
+          <a:p>
+            <a:pPr marL="0" indent="0">
+              <a:buNone/>
+            </a:pPr>
+            <a:r>
+              <a:rPr lang="en-US" sz="1050" dirty="0">
+                <a:solidFill>
+                  <a:schemeClr val="tx1"/>
+                </a:solidFill>
+                <a:latin typeface="JetBrains Mono" pitchFamily="34" charset="0"/>
+                <a:ea typeface="JetBrains Mono" pitchFamily="34" charset="-122"/>
+                <a:cs typeface="JetBrains Mono" pitchFamily="34" charset="-120"/>
+              </a:rPr>
+              <a:t>    result = external_tool()</a:t>
+            </a:r>
+            <a:endParaRPr lang="en-US" sz="1050" dirty="0"/>
+          </a:p>
+          <a:p>
+            <a:pPr marL="0" indent="0">
+              <a:buNone/>
+            </a:pPr>
+            <a:r>
+              <a:rPr lang="en-US" sz="1050" dirty="0">
+                <a:solidFill>
+                  <a:schemeClr val="tx1"/>
+                </a:solidFill>
+                <a:latin typeface="JetBrains Mono" pitchFamily="34" charset="0"/>
+                <a:ea typeface="JetBrains Mono" pitchFamily="34" charset="-122"/>
+                <a:cs typeface="JetBrains Mono" pitchFamily="34" charset="-120"/>
+              </a:rPr>
+              <a:t>except Exception:</a:t>
+            </a:r>
+            <a:endParaRPr lang="en-US" sz="1050" dirty="0"/>
+          </a:p>
+          <a:p>
+            <a:pPr marL="0" indent="0">
+              <a:buNone/>
+            </a:pPr>
+            <a:r>
+              <a:rPr lang="en-US" sz="1050" dirty="0">
+                <a:solidFill>
+                  <a:schemeClr val="tx1"/>
+                </a:solidFill>
+                <a:latin typeface="JetBrains Mono" pitchFamily="34" charset="0"/>
+                <a:ea typeface="JetBrains Mono" pitchFamily="34" charset="-122"/>
+                <a:cs typeface="JetBrains Mono" pitchFamily="34" charset="-120"/>
+              </a:rPr>
+              <a:t>    agent.complete(decision, "failed")</a:t>
+            </a:r>
+            <a:endParaRPr lang="en-US" sz="1050" dirty="0"/>
+          </a:p>
+          <a:p>
+            <a:pPr marL="0" indent="0">
+              <a:buNone/>
+            </a:pPr>
+            <a:r>
+              <a:rPr lang="en-US" sz="1050" dirty="0">
+                <a:solidFill>
+                  <a:schemeClr val="tx1"/>
+                </a:solidFill>
+                <a:latin typeface="JetBrains Mono" pitchFamily="34" charset="0"/>
+                <a:ea typeface="JetBrains Mono" pitchFamily="34" charset="-122"/>
+                <a:cs typeface="JetBrains Mono" pitchFamily="34" charset="-120"/>
+              </a:rPr>
+              <a:t>    raise</a:t>
+            </a:r>
+            <a:endParaRPr lang="en-US" sz="1050" dirty="0"/>
+          </a:p>
+          <a:p>
+            <a:pPr marL="0" indent="0">
+              <a:buNone/>
+            </a:pPr>
+            <a:r>
+              <a:rPr lang="en-US" sz="1050" dirty="0">
+                <a:solidFill>
+                  <a:schemeClr val="tx1"/>
+                </a:solidFill>
+                <a:latin typeface="JetBrains Mono" pitchFamily="34" charset="0"/>
+                <a:ea typeface="JetBrains Mono" pitchFamily="34" charset="-122"/>
+                <a:cs typeface="JetBrains Mono" pitchFamily="34" charset="-120"/>
+              </a:rPr>
+              <a:t>agent.complete(decision, "succeeded")</a:t>
+            </a:r>
+            <a:endParaRPr lang="en-US" sz="1050" dirty="0"/>
+          </a:p>
+          <a:p>
+            <a:pPr marL="0" indent="0">
+              <a:buNone/>
+            </a:pPr>
+            <a:endParaRPr lang="en-US" sz="1050" dirty="0"/>
+          </a:p>
+          <a:p>
+            <a:pPr marL="0" indent="0">
+              <a:buNone/>
+            </a:pPr>
+            <a:r>
+              <a:rPr lang="en-US" sz="1050" dirty="0">
+                <a:solidFill>
+                  <a:schemeClr val="tx1"/>
+                </a:solidFill>
+                <a:latin typeface="JetBrains Mono" pitchFamily="34" charset="0"/>
+                <a:ea typeface="JetBrains Mono" pitchFamily="34" charset="-122"/>
+                <a:cs typeface="JetBrains Mono" pitchFamily="34" charset="-120"/>
+              </a:rPr>
+              <a:t>outcome = reviewer.execute(</a:t>
+            </a:r>
+            <a:endParaRPr lang="en-US" sz="1050" dirty="0"/>
+          </a:p>
+          <a:p>
+            <a:pPr marL="0" indent="0">
+              <a:buNone/>
+            </a:pPr>
+            <a:r>
+              <a:rPr lang="en-US" sz="1050" dirty="0">
+                <a:solidFill>
+                  <a:schemeClr val="tx1"/>
+                </a:solidFill>
+                <a:latin typeface="JetBrains Mono" pitchFamily="34" charset="0"/>
+                <a:ea typeface="JetBrains Mono" pitchFamily="34" charset="-122"/>
+                <a:cs typeface="JetBrains Mono" pitchFamily="34" charset="-120"/>
+              </a:rPr>
+              <a:t>    "transfer_funds", {"amount": 125, ...},</a:t>
+            </a:r>
+            <a:endParaRPr lang="en-US" sz="1050" dirty="0"/>
+          </a:p>
+          <a:p>
+            <a:pPr marL="0" indent="0">
+              <a:buNone/>
+            </a:pPr>
+            <a:r>
+              <a:rPr lang="en-US" sz="1050" dirty="0">
+                <a:solidFill>
+                  <a:schemeClr val="tx1"/>
+                </a:solidFill>
+                <a:latin typeface="JetBrains Mono" pitchFamily="34" charset="0"/>
+                <a:ea typeface="JetBrains Mono" pitchFamily="34" charset="-122"/>
+                <a:cs typeface="JetBrains Mono" pitchFamily="34" charset="-120"/>
+              </a:rPr>
+              <a:t>    idempotency_key="invoice-4471-payment")</a:t>
+            </a:r>
+            <a:endParaRPr lang="en-US" sz="1050" dirty="0"/>
+          </a:p>
+        </p:txBody>
+      </p:sp>
+      <p:sp>
+        <p:nvSpPr>
+          <p:cNvPr id="6" name="Callout receipts"/>
+          <p:cNvSpPr/>
+          <p:nvPr/>
+        </p:nvSpPr>
+        <p:spPr>
+          <a:xfrm>
+            <a:off x="5623560" y="1325880"/>
+            <a:ext cx="2944368" cy="1554480"/>
+          </a:xfrm>
+          <a:prstGeom prst="rect">
+            <a:avLst/>
+          </a:prstGeom>
+          <a:solidFill>
+            <a:schemeClr val="bg2"/>
+          </a:solidFill>
+          <a:ln/>
+        </p:spPr>
+        <p:txBody>
+          <a:bodyPr/>
+          <a:lstStyle/>
+          <a:p>
+            <a:endParaRPr lang="en-US"/>
+          </a:p>
+        </p:txBody>
+      </p:sp>
+      <p:sp>
+        <p:nvSpPr>
+          <p:cNvPr id="7" name="Text 5"/>
+          <p:cNvSpPr txBox="1"/>
+          <p:nvPr/>
+        </p:nvSpPr>
+        <p:spPr>
+          <a:xfrm>
+            <a:off x="5806440" y="1490472"/>
+            <a:ext cx="2578608" cy="548640"/>
+          </a:xfrm>
+          <a:prstGeom prst="rect">
+            <a:avLst/>
+          </a:prstGeom>
+          <a:noFill/>
+          <a:ln/>
+        </p:spPr>
+        <p:txBody>
+          <a:bodyPr wrap="square" lIns="0" tIns="0" rIns="0" bIns="0" rtlCol="0" anchor="ctr"/>
+          <a:lstStyle/>
+          <a:p>
+            <a:pPr marL="0" indent="0">
+              <a:buNone/>
+            </a:pPr>
+            <a:r>
+              <a:rPr lang="en-US" sz="2850" b="1" dirty="0">
+                <a:solidFill>
+                  <a:schemeClr val="accent1"/>
+                </a:solidFill>
+              </a:rPr>
+              <a:t>Receipts</a:t>
+            </a:r>
+            <a:endParaRPr lang="en-US" sz="2850" dirty="0"/>
+          </a:p>
+        </p:txBody>
+      </p:sp>
+      <p:sp>
+        <p:nvSpPr>
+          <p:cNvPr id="8" name="Text 6"/>
+          <p:cNvSpPr txBox="1"/>
+          <p:nvPr/>
+        </p:nvSpPr>
+        <p:spPr>
+          <a:xfrm>
+            <a:off x="5806440" y="2075688"/>
+            <a:ext cx="2624328" cy="685800"/>
+          </a:xfrm>
+          <a:prstGeom prst="rect">
+            <a:avLst/>
+          </a:prstGeom>
+          <a:noFill/>
+          <a:ln/>
+        </p:spPr>
+        <p:txBody>
+          <a:bodyPr wrap="square" lIns="0" tIns="0" rIns="0" bIns="0" rtlCol="0" anchor="t"/>
+          <a:lstStyle/>
+          <a:p>
+            <a:pPr marL="0" indent="0">
+              <a:buNone/>
+            </a:pPr>
+            <a:r>
+              <a:rPr lang="en-US" sz="1300" dirty="0">
+                <a:solidFill>
+                  <a:schemeClr val="tx1"/>
+                </a:solidFill>
+              </a:rPr>
+              <a:t>Tools report succeeded or failed;</a:t>
+            </a:r>
+            <a:endParaRPr lang="en-US" sz="1300" dirty="0"/>
+          </a:p>
+          <a:p>
+            <a:pPr marL="0" indent="0">
+              <a:buNone/>
+            </a:pPr>
+            <a:r>
+              <a:rPr lang="en-US" sz="1300" dirty="0">
+                <a:solidFill>
+                  <a:schemeClr val="tx1"/>
+                </a:solidFill>
+              </a:rPr>
+              <a:t>the dashboard counts both</a:t>
+            </a:r>
+            <a:endParaRPr lang="en-US" sz="1300" dirty="0"/>
+          </a:p>
+        </p:txBody>
+      </p:sp>
+      <p:sp>
+        <p:nvSpPr>
+          <p:cNvPr id="9" name="Callout retries"/>
+          <p:cNvSpPr/>
+          <p:nvPr/>
+        </p:nvSpPr>
+        <p:spPr>
+          <a:xfrm>
+            <a:off x="5623560" y="3017520"/>
+            <a:ext cx="2944368" cy="1554480"/>
+          </a:xfrm>
+          <a:prstGeom prst="rect">
+            <a:avLst/>
+          </a:prstGeom>
+          <a:solidFill>
+            <a:schemeClr val="bg2"/>
+          </a:solidFill>
+          <a:ln/>
+        </p:spPr>
+        <p:txBody>
+          <a:bodyPr/>
+          <a:lstStyle/>
+          <a:p>
+            <a:endParaRPr lang="en-US"/>
+          </a:p>
+        </p:txBody>
+      </p:sp>
+      <p:sp>
+        <p:nvSpPr>
+          <p:cNvPr id="10" name="Text 8"/>
+          <p:cNvSpPr txBox="1"/>
+          <p:nvPr/>
+        </p:nvSpPr>
+        <p:spPr>
+          <a:xfrm>
+            <a:off x="5806440" y="3182112"/>
+            <a:ext cx="2578608" cy="548640"/>
+          </a:xfrm>
+          <a:prstGeom prst="rect">
+            <a:avLst/>
+          </a:prstGeom>
+          <a:noFill/>
+          <a:ln/>
+        </p:spPr>
+        <p:txBody>
+          <a:bodyPr wrap="square" lIns="0" tIns="0" rIns="0" bIns="0" rtlCol="0" anchor="ctr"/>
+          <a:lstStyle/>
+          <a:p>
+            <a:pPr marL="0" indent="0">
+              <a:buNone/>
+            </a:pPr>
+            <a:r>
+              <a:rPr lang="en-US" sz="2850" b="1" dirty="0">
+                <a:solidFill>
+                  <a:schemeClr val="accent1"/>
+                </a:solidFill>
+              </a:rPr>
+              <a:t>Retry-safe</a:t>
+            </a:r>
+            <a:endParaRPr lang="en-US" sz="2850" dirty="0"/>
+          </a:p>
+        </p:txBody>
+      </p:sp>
+      <p:sp>
+        <p:nvSpPr>
+          <p:cNvPr id="11" name="Text 9"/>
+          <p:cNvSpPr txBox="1"/>
+          <p:nvPr/>
+        </p:nvSpPr>
+        <p:spPr>
+          <a:xfrm>
+            <a:off x="5806440" y="3767328"/>
+            <a:ext cx="2624328" cy="685800"/>
+          </a:xfrm>
+          <a:prstGeom prst="rect">
+            <a:avLst/>
+          </a:prstGeom>
+          <a:noFill/>
+          <a:ln/>
+        </p:spPr>
+        <p:txBody>
+          <a:bodyPr wrap="square" lIns="0" tIns="0" rIns="0" bIns="0" rtlCol="0" anchor="t"/>
+          <a:lstStyle/>
+          <a:p>
+            <a:pPr marL="0" indent="0">
+              <a:buNone/>
+            </a:pPr>
+            <a:r>
+              <a:rPr lang="en-US" sz="1300" dirty="0">
+                <a:solidFill>
+                  <a:schemeClr val="tx1"/>
+                </a:solidFill>
+              </a:rPr>
+              <a:t>Idempotency keys: a lost reply</a:t>
+            </a:r>
+            <a:endParaRPr lang="en-US" sz="1300" dirty="0"/>
+          </a:p>
+          <a:p>
+            <a:pPr marL="0" indent="0">
+              <a:buNone/>
+            </a:pPr>
+            <a:r>
+              <a:rPr lang="en-US" sz="1300" dirty="0">
+                <a:solidFill>
+                  <a:schemeClr val="tx1"/>
+                </a:solidFill>
+              </a:rPr>
+              <a:t>never pays twice</a:t>
+            </a:r>
+            <a:endParaRPr lang="en-US" sz="1300" dirty="0"/>
+          </a:p>
+        </p:txBody>
+      </p:sp>
+    </p:spTree>
+  </p:cSld>
+  <p:clrMapOvr>
+    <a:masterClrMapping/>
+  </p:clrMapOvr>
+</p:sld>
+</file>
+
+<file path=ppt/slides/slide13.xml><?xml version="1.0" encoding="utf-8"?>
 <p:sld xmlns:a="http://schemas.openxmlformats.org/drawingml/2006/main" xmlns:r="http://schemas.openxmlformats.org/officeDocument/2006/relationships" xmlns:p="http://schemas.openxmlformats.org/presentationml/2006/main">
   <p:cSld name="Slide 12">
     <p:spTree>
@@ -3948,7 +5027,7 @@
                 <a:ea typeface="JetBrains Mono" pitchFamily="34" charset="-122"/>
                 <a:cs typeface="JetBrains Mono" pitchFamily="34" charset="-120"/>
               </a:rPr>
-              <a:t>13 / 15</a:t>
+              <a:t>13 / 16</a:t>
             </a:r>
             <a:endParaRPr lang="en-US" sz="1130" dirty="0"/>
           </a:p>
@@ -4243,7 +5322,7 @@
 </p:sld>
 </file>
 
-<file path=ppt/slides/slide13.xml><?xml version="1.0" encoding="utf-8"?>
+<file path=ppt/slides/slide14.xml><?xml version="1.0" encoding="utf-8"?>
 <p:sld xmlns:a="http://schemas.openxmlformats.org/drawingml/2006/main" xmlns:r="http://schemas.openxmlformats.org/officeDocument/2006/relationships" xmlns:p="http://schemas.openxmlformats.org/presentationml/2006/main">
   <p:cSld name="Slide 13">
     <p:spTree>
@@ -4293,7 +5372,7 @@
                 <a:ea typeface="JetBrains Mono" pitchFamily="34" charset="-122"/>
                 <a:cs typeface="JetBrains Mono" pitchFamily="34" charset="-120"/>
               </a:rPr>
-              <a:t>14 / 15</a:t>
+              <a:t>14 / 16</a:t>
             </a:r>
             <a:endParaRPr lang="en-US" sz="1130" dirty="0"/>
           </a:p>
@@ -4685,7 +5764,7 @@
 </p:sld>
 </file>
 
-<file path=ppt/slides/slide14.xml><?xml version="1.0" encoding="utf-8"?>
+<file path=ppt/slides/slide15.xml><?xml version="1.0" encoding="utf-8"?>
 <p:sld xmlns:a="http://schemas.openxmlformats.org/drawingml/2006/main" xmlns:r="http://schemas.openxmlformats.org/officeDocument/2006/relationships" xmlns:p="http://schemas.openxmlformats.org/presentationml/2006/main">
   <p:cSld name="Slide 14">
     <p:spTree>
@@ -4735,7 +5814,7 @@
                 <a:ea typeface="JetBrains Mono" pitchFamily="34" charset="-122"/>
                 <a:cs typeface="JetBrains Mono" pitchFamily="34" charset="-120"/>
               </a:rPr>
-              <a:t>15 / 15</a:t>
+              <a:t>16 / 16</a:t>
             </a:r>
             <a:endParaRPr lang="en-US" sz="1130" dirty="0"/>
           </a:p>
@@ -5309,606 +6388,6 @@
               <a:t>Real-data evaluation uses the AI Village dataset: AI Digest, "AI Village dataset", 2026.</a:t>
             </a:r>
             <a:endParaRPr lang="en-US" sz="1100" dirty="0"/>
-          </a:p>
-        </p:txBody>
-      </p:sp>
-    </p:spTree>
-  </p:cSld>
-  <p:clrMapOvr>
-    <a:masterClrMapping/>
-  </p:clrMapOvr>
-</p:sld>
-</file>
-
-<file path=ppt/slides/slide15.xml><?xml version="1.0" encoding="utf-8"?>
-<p:sld xmlns:a="http://schemas.openxmlformats.org/drawingml/2006/main" xmlns:r="http://schemas.openxmlformats.org/officeDocument/2006/relationships" xmlns:p="http://schemas.openxmlformats.org/presentationml/2006/main">
-  <p:cSld name="Slide 11">
-    <p:spTree>
-      <p:nvGrpSpPr>
-        <p:cNvPr id="1" name=""/>
-        <p:cNvGrpSpPr/>
-        <p:nvPr/>
-      </p:nvGrpSpPr>
-      <p:grpSpPr>
-        <a:xfrm>
-          <a:off x="0" y="0"/>
-          <a:ext cx="0" cy="0"/>
-          <a:chOff x="0" y="0"/>
-          <a:chExt cx="0" cy="0"/>
-        </a:xfrm>
-      </p:grpSpPr>
-      <p:sp>
-        <p:nvSpPr>
-          <p:cNvPr id="2" name="Page number"/>
-          <p:cNvSpPr txBox="1"/>
-          <p:nvPr/>
-        </p:nvSpPr>
-        <p:spPr>
-          <a:xfrm>
-            <a:off x="7653528" y="4864608"/>
-            <a:ext cx="914400" cy="219456"/>
-          </a:xfrm>
-          <a:prstGeom prst="rect">
-            <a:avLst/>
-          </a:prstGeom>
-          <a:noFill/>
-          <a:ln/>
-        </p:spPr>
-        <p:txBody>
-          <a:bodyPr wrap="square" lIns="0" tIns="0" rIns="0" bIns="0" rtlCol="0" anchor="ctr"/>
-          <a:lstStyle/>
-          <a:p>
-            <a:pPr marL="0" indent="0" algn="r">
-              <a:buNone/>
-            </a:pPr>
-            <a:r>
-              <a:rPr lang="en-US" sz="1130" dirty="0">
-                <a:solidFill>
-                  <a:schemeClr val="tx2"/>
-                </a:solidFill>
-                <a:latin typeface="JetBrains Mono" pitchFamily="34" charset="0"/>
-                <a:ea typeface="JetBrains Mono" pitchFamily="34" charset="-122"/>
-                <a:cs typeface="JetBrains Mono" pitchFamily="34" charset="-120"/>
-              </a:rPr>
-              <a:t>12 / 15</a:t>
-            </a:r>
-            <a:endParaRPr lang="en-US" sz="1130" dirty="0"/>
-          </a:p>
-        </p:txBody>
-      </p:sp>
-      <p:sp>
-        <p:nvSpPr>
-          <p:cNvPr id="3" name="Text 3"/>
-          <p:cNvSpPr>
-            <a:spLocks noGrp="1"/>
-          </p:cNvSpPr>
-          <p:nvPr>
-            <p:ph type="title" idx="103" hasCustomPrompt="1"/>
-          </p:nvPr>
-        </p:nvSpPr>
-        <p:spPr>
-          <a:xfrm>
-            <a:off x="566928" y="566928"/>
-            <a:ext cx="8001000" cy="512064"/>
-          </a:xfrm>
-          <a:prstGeom prst="rect">
-            <a:avLst/>
-          </a:prstGeom>
-          <a:noFill/>
-          <a:ln/>
-        </p:spPr>
-        <p:txBody>
-          <a:bodyPr wrap="square" lIns="0" tIns="0" rIns="0" bIns="0" rtlCol="0" anchor="ctr"/>
-          <a:lstStyle/>
-          <a:p>
-            <a:pPr marL="0" indent="0" algn="l">
-              <a:buNone/>
-            </a:pPr>
-            <a:r>
-              <a:rPr lang="en-US" sz="2850" b="1" dirty="0">
-                <a:solidFill>
-                  <a:schemeClr val="tx1"/>
-                </a:solidFill>
-              </a:rPr>
-              <a:t>Allowed is not done: receipts and safe retries</a:t>
-            </a:r>
-            <a:endParaRPr lang="en-US" sz="2850" dirty="0"/>
-          </a:p>
-        </p:txBody>
-      </p:sp>
-      <p:sp>
-        <p:nvSpPr>
-          <p:cNvPr id="4" name="Receipt code"/>
-          <p:cNvSpPr/>
-          <p:nvPr/>
-        </p:nvSpPr>
-        <p:spPr>
-          <a:xfrm>
-            <a:off x="566928" y="1325880"/>
-            <a:ext cx="4846320" cy="3246120"/>
-          </a:xfrm>
-          <a:prstGeom prst="rect">
-            <a:avLst/>
-          </a:prstGeom>
-          <a:solidFill>
-            <a:schemeClr val="bg2"/>
-          </a:solidFill>
-          <a:ln/>
-        </p:spPr>
-        <p:txBody>
-          <a:bodyPr/>
-          <a:lstStyle/>
-          <a:p>
-            <a:endParaRPr lang="en-US"/>
-          </a:p>
-        </p:txBody>
-      </p:sp>
-      <p:sp>
-        <p:nvSpPr>
-          <p:cNvPr id="5" name="Guard snippet"/>
-          <p:cNvSpPr txBox="1"/>
-          <p:nvPr/>
-        </p:nvSpPr>
-        <p:spPr>
-          <a:xfrm>
-            <a:off x="731520" y="1463040"/>
-            <a:ext cx="4572000" cy="2971800"/>
-          </a:xfrm>
-          <a:prstGeom prst="rect">
-            <a:avLst/>
-          </a:prstGeom>
-          <a:noFill/>
-          <a:ln/>
-        </p:spPr>
-        <p:txBody>
-          <a:bodyPr wrap="square" lIns="0" tIns="0" rIns="0" bIns="0" rtlCol="0" anchor="ctr"/>
-          <a:lstStyle/>
-          <a:p>
-            <a:pPr marL="0" indent="0">
-              <a:buNone/>
-            </a:pPr>
-            <a:r>
-              <a:rPr lang="en-US" sz="1050" dirty="0">
-                <a:solidFill>
-                  <a:schemeClr val="tx1"/>
-                </a:solidFill>
-                <a:latin typeface="JetBrains Mono" pitchFamily="34" charset="0"/>
-                <a:ea typeface="JetBrains Mono" pitchFamily="34" charset="-122"/>
-                <a:cs typeface="JetBrains Mono" pitchFamily="34" charset="-120"/>
-              </a:rPr>
-              <a:t>decision = agent.check("tool", "mock:fs.read")</a:t>
-            </a:r>
-            <a:endParaRPr lang="en-US" sz="1050" dirty="0"/>
-          </a:p>
-          <a:p>
-            <a:pPr marL="0" indent="0">
-              <a:buNone/>
-            </a:pPr>
-            <a:r>
-              <a:rPr lang="en-US" sz="1050" dirty="0">
-                <a:solidFill>
-                  <a:schemeClr val="tx1"/>
-                </a:solidFill>
-                <a:latin typeface="JetBrains Mono" pitchFamily="34" charset="0"/>
-                <a:ea typeface="JetBrains Mono" pitchFamily="34" charset="-122"/>
-                <a:cs typeface="JetBrains Mono" pitchFamily="34" charset="-120"/>
-              </a:rPr>
-              <a:t>if not decision.allowed:</a:t>
-            </a:r>
-            <a:endParaRPr lang="en-US" sz="1050" dirty="0"/>
-          </a:p>
-          <a:p>
-            <a:pPr marL="0" indent="0">
-              <a:buNone/>
-            </a:pPr>
-            <a:r>
-              <a:rPr lang="en-US" sz="1050" dirty="0">
-                <a:solidFill>
-                  <a:schemeClr val="tx1"/>
-                </a:solidFill>
-                <a:latin typeface="JetBrains Mono" pitchFamily="34" charset="0"/>
-                <a:ea typeface="JetBrains Mono" pitchFamily="34" charset="-122"/>
-                <a:cs typeface="JetBrains Mono" pitchFamily="34" charset="-120"/>
-              </a:rPr>
-              <a:t>    raise PolicyViolation(decision)</a:t>
-            </a:r>
-            <a:endParaRPr lang="en-US" sz="1050" dirty="0"/>
-          </a:p>
-          <a:p>
-            <a:pPr marL="0" indent="0">
-              <a:buNone/>
-            </a:pPr>
-            <a:r>
-              <a:rPr lang="en-US" sz="1050" dirty="0">
-                <a:solidFill>
-                  <a:schemeClr val="tx1"/>
-                </a:solidFill>
-                <a:latin typeface="JetBrains Mono" pitchFamily="34" charset="0"/>
-                <a:ea typeface="JetBrains Mono" pitchFamily="34" charset="-122"/>
-                <a:cs typeface="JetBrains Mono" pitchFamily="34" charset="-120"/>
-              </a:rPr>
-              <a:t>try:</a:t>
-            </a:r>
-            <a:endParaRPr lang="en-US" sz="1050" dirty="0"/>
-          </a:p>
-          <a:p>
-            <a:pPr marL="0" indent="0">
-              <a:buNone/>
-            </a:pPr>
-            <a:r>
-              <a:rPr lang="en-US" sz="1050" dirty="0">
-                <a:solidFill>
-                  <a:schemeClr val="tx1"/>
-                </a:solidFill>
-                <a:latin typeface="JetBrains Mono" pitchFamily="34" charset="0"/>
-                <a:ea typeface="JetBrains Mono" pitchFamily="34" charset="-122"/>
-                <a:cs typeface="JetBrains Mono" pitchFamily="34" charset="-120"/>
-              </a:rPr>
-              <a:t>    result = external_tool()</a:t>
-            </a:r>
-            <a:endParaRPr lang="en-US" sz="1050" dirty="0"/>
-          </a:p>
-          <a:p>
-            <a:pPr marL="0" indent="0">
-              <a:buNone/>
-            </a:pPr>
-            <a:r>
-              <a:rPr lang="en-US" sz="1050" dirty="0">
-                <a:solidFill>
-                  <a:schemeClr val="tx1"/>
-                </a:solidFill>
-                <a:latin typeface="JetBrains Mono" pitchFamily="34" charset="0"/>
-                <a:ea typeface="JetBrains Mono" pitchFamily="34" charset="-122"/>
-                <a:cs typeface="JetBrains Mono" pitchFamily="34" charset="-120"/>
-              </a:rPr>
-              <a:t>except Exception:</a:t>
-            </a:r>
-            <a:endParaRPr lang="en-US" sz="1050" dirty="0"/>
-          </a:p>
-          <a:p>
-            <a:pPr marL="0" indent="0">
-              <a:buNone/>
-            </a:pPr>
-            <a:r>
-              <a:rPr lang="en-US" sz="1050" dirty="0">
-                <a:solidFill>
-                  <a:schemeClr val="tx1"/>
-                </a:solidFill>
-                <a:latin typeface="JetBrains Mono" pitchFamily="34" charset="0"/>
-                <a:ea typeface="JetBrains Mono" pitchFamily="34" charset="-122"/>
-                <a:cs typeface="JetBrains Mono" pitchFamily="34" charset="-120"/>
-              </a:rPr>
-              <a:t>    agent.complete(decision, "failed")</a:t>
-            </a:r>
-            <a:endParaRPr lang="en-US" sz="1050" dirty="0"/>
-          </a:p>
-          <a:p>
-            <a:pPr marL="0" indent="0">
-              <a:buNone/>
-            </a:pPr>
-            <a:r>
-              <a:rPr lang="en-US" sz="1050" dirty="0">
-                <a:solidFill>
-                  <a:schemeClr val="tx1"/>
-                </a:solidFill>
-                <a:latin typeface="JetBrains Mono" pitchFamily="34" charset="0"/>
-                <a:ea typeface="JetBrains Mono" pitchFamily="34" charset="-122"/>
-                <a:cs typeface="JetBrains Mono" pitchFamily="34" charset="-120"/>
-              </a:rPr>
-              <a:t>    raise</a:t>
-            </a:r>
-            <a:endParaRPr lang="en-US" sz="1050" dirty="0"/>
-          </a:p>
-          <a:p>
-            <a:pPr marL="0" indent="0">
-              <a:buNone/>
-            </a:pPr>
-            <a:r>
-              <a:rPr lang="en-US" sz="1050" dirty="0">
-                <a:solidFill>
-                  <a:schemeClr val="tx1"/>
-                </a:solidFill>
-                <a:latin typeface="JetBrains Mono" pitchFamily="34" charset="0"/>
-                <a:ea typeface="JetBrains Mono" pitchFamily="34" charset="-122"/>
-                <a:cs typeface="JetBrains Mono" pitchFamily="34" charset="-120"/>
-              </a:rPr>
-              <a:t>agent.complete(decision, "succeeded")</a:t>
-            </a:r>
-            <a:endParaRPr lang="en-US" sz="1050" dirty="0"/>
-          </a:p>
-          <a:p>
-            <a:pPr marL="0" indent="0">
-              <a:buNone/>
-            </a:pPr>
-            <a:r>
-              <a:rPr lang="en-US" sz="1050" dirty="0">
-                <a:solidFill>
-                  <a:schemeClr val="tx1"/>
-                </a:solidFill>
-                <a:latin typeface="JetBrains Mono" pitchFamily="34" charset="0"/>
-                <a:ea typeface="JetBrains Mono" pitchFamily="34" charset="-122"/>
-                <a:cs typeface="JetBrains Mono" pitchFamily="34" charset="-120"/>
-              </a:rPr>
-              <a:t/>
-            </a:r>
-            <a:endParaRPr lang="en-US" sz="1050" dirty="0"/>
-          </a:p>
-          <a:p>
-            <a:pPr marL="0" indent="0">
-              <a:buNone/>
-            </a:pPr>
-            <a:r>
-              <a:rPr lang="en-US" sz="1050" dirty="0">
-                <a:solidFill>
-                  <a:schemeClr val="tx1"/>
-                </a:solidFill>
-                <a:latin typeface="JetBrains Mono" pitchFamily="34" charset="0"/>
-                <a:ea typeface="JetBrains Mono" pitchFamily="34" charset="-122"/>
-                <a:cs typeface="JetBrains Mono" pitchFamily="34" charset="-120"/>
-              </a:rPr>
-              <a:t>outcome = reviewer.execute(</a:t>
-            </a:r>
-            <a:endParaRPr lang="en-US" sz="1050" dirty="0"/>
-          </a:p>
-          <a:p>
-            <a:pPr marL="0" indent="0">
-              <a:buNone/>
-            </a:pPr>
-            <a:r>
-              <a:rPr lang="en-US" sz="1050" dirty="0">
-                <a:solidFill>
-                  <a:schemeClr val="tx1"/>
-                </a:solidFill>
-                <a:latin typeface="JetBrains Mono" pitchFamily="34" charset="0"/>
-                <a:ea typeface="JetBrains Mono" pitchFamily="34" charset="-122"/>
-                <a:cs typeface="JetBrains Mono" pitchFamily="34" charset="-120"/>
-              </a:rPr>
-              <a:t>    "transfer_funds", {"amount": 125, ...},</a:t>
-            </a:r>
-            <a:endParaRPr lang="en-US" sz="1050" dirty="0"/>
-          </a:p>
-          <a:p>
-            <a:pPr marL="0" indent="0">
-              <a:buNone/>
-            </a:pPr>
-            <a:r>
-              <a:rPr lang="en-US" sz="1050" dirty="0">
-                <a:solidFill>
-                  <a:schemeClr val="tx1"/>
-                </a:solidFill>
-                <a:latin typeface="JetBrains Mono" pitchFamily="34" charset="0"/>
-                <a:ea typeface="JetBrains Mono" pitchFamily="34" charset="-122"/>
-                <a:cs typeface="JetBrains Mono" pitchFamily="34" charset="-120"/>
-              </a:rPr>
-              <a:t>    idempotency_key="invoice-4471-payment")</a:t>
-            </a:r>
-            <a:endParaRPr lang="en-US" sz="1050" dirty="0"/>
-          </a:p>
-        </p:txBody>
-      </p:sp>
-      <p:sp>
-        <p:nvSpPr>
-          <p:cNvPr id="6" name="Callout receipts"/>
-          <p:cNvSpPr/>
-          <p:nvPr/>
-        </p:nvSpPr>
-        <p:spPr>
-          <a:xfrm>
-            <a:off x="5623560" y="1325880"/>
-            <a:ext cx="2944368" cy="1554480"/>
-          </a:xfrm>
-          <a:prstGeom prst="rect">
-            <a:avLst/>
-          </a:prstGeom>
-          <a:solidFill>
-            <a:schemeClr val="bg2"/>
-          </a:solidFill>
-          <a:ln/>
-        </p:spPr>
-        <p:txBody>
-          <a:bodyPr/>
-          <a:lstStyle/>
-          <a:p>
-            <a:endParaRPr lang="en-US"/>
-          </a:p>
-        </p:txBody>
-      </p:sp>
-      <p:sp>
-        <p:nvSpPr>
-          <p:cNvPr id="7" name="Text 5"/>
-          <p:cNvSpPr txBox="1"/>
-          <p:nvPr/>
-        </p:nvSpPr>
-        <p:spPr>
-          <a:xfrm>
-            <a:off x="5806440" y="1490472"/>
-            <a:ext cx="2578608" cy="548640"/>
-          </a:xfrm>
-          <a:prstGeom prst="rect">
-            <a:avLst/>
-          </a:prstGeom>
-          <a:noFill/>
-          <a:ln/>
-        </p:spPr>
-        <p:txBody>
-          <a:bodyPr wrap="square" lIns="0" tIns="0" rIns="0" bIns="0" rtlCol="0" anchor="ctr"/>
-          <a:lstStyle/>
-          <a:p>
-            <a:pPr marL="0" indent="0">
-              <a:buNone/>
-            </a:pPr>
-            <a:r>
-              <a:rPr lang="en-US" sz="2850" b="1" dirty="0">
-                <a:solidFill>
-                  <a:schemeClr val="accent1"/>
-                </a:solidFill>
-              </a:rPr>
-              <a:t>Receipts</a:t>
-            </a:r>
-            <a:endParaRPr lang="en-US" sz="2850" dirty="0"/>
-          </a:p>
-        </p:txBody>
-      </p:sp>
-      <p:sp>
-        <p:nvSpPr>
-          <p:cNvPr id="8" name="Text 6"/>
-          <p:cNvSpPr txBox="1"/>
-          <p:nvPr/>
-        </p:nvSpPr>
-        <p:spPr>
-          <a:xfrm>
-            <a:off x="5806440" y="2075688"/>
-            <a:ext cx="2624328" cy="685800"/>
-          </a:xfrm>
-          <a:prstGeom prst="rect">
-            <a:avLst/>
-          </a:prstGeom>
-          <a:noFill/>
-          <a:ln/>
-        </p:spPr>
-        <p:txBody>
-          <a:bodyPr wrap="square" lIns="0" tIns="0" rIns="0" bIns="0" rtlCol="0" anchor="t"/>
-          <a:lstStyle/>
-          <a:p>
-            <a:pPr marL="0" indent="0">
-              <a:buNone/>
-            </a:pPr>
-            <a:r>
-              <a:rPr lang="en-US" sz="1300" dirty="0">
-                <a:solidFill>
-                  <a:schemeClr val="tx1"/>
-                </a:solidFill>
-              </a:rPr>
-              <a:t>Tools report succeeded or failed;</a:t>
-            </a:r>
-            <a:endParaRPr lang="en-US" sz="1300" dirty="0"/>
-          </a:p>
-          <a:p>
-            <a:pPr marL="0" indent="0">
-              <a:buNone/>
-            </a:pPr>
-            <a:r>
-              <a:rPr lang="en-US" sz="1300" dirty="0">
-                <a:solidFill>
-                  <a:schemeClr val="tx1"/>
-                </a:solidFill>
-              </a:rPr>
-              <a:t>the dashboard counts both</a:t>
-            </a:r>
-            <a:endParaRPr lang="en-US" sz="1300" dirty="0"/>
-          </a:p>
-        </p:txBody>
-      </p:sp>
-      <p:sp>
-        <p:nvSpPr>
-          <p:cNvPr id="9" name="Callout retries"/>
-          <p:cNvSpPr/>
-          <p:nvPr/>
-        </p:nvSpPr>
-        <p:spPr>
-          <a:xfrm>
-            <a:off x="5623560" y="3017520"/>
-            <a:ext cx="2944368" cy="1554480"/>
-          </a:xfrm>
-          <a:prstGeom prst="rect">
-            <a:avLst/>
-          </a:prstGeom>
-          <a:solidFill>
-            <a:schemeClr val="bg2"/>
-          </a:solidFill>
-          <a:ln/>
-        </p:spPr>
-        <p:txBody>
-          <a:bodyPr/>
-          <a:lstStyle/>
-          <a:p>
-            <a:endParaRPr lang="en-US"/>
-          </a:p>
-        </p:txBody>
-      </p:sp>
-      <p:sp>
-        <p:nvSpPr>
-          <p:cNvPr id="10" name="Text 8"/>
-          <p:cNvSpPr txBox="1"/>
-          <p:nvPr/>
-        </p:nvSpPr>
-        <p:spPr>
-          <a:xfrm>
-            <a:off x="5806440" y="3182112"/>
-            <a:ext cx="2578608" cy="548640"/>
-          </a:xfrm>
-          <a:prstGeom prst="rect">
-            <a:avLst/>
-          </a:prstGeom>
-          <a:noFill/>
-          <a:ln/>
-        </p:spPr>
-        <p:txBody>
-          <a:bodyPr wrap="square" lIns="0" tIns="0" rIns="0" bIns="0" rtlCol="0" anchor="ctr"/>
-          <a:lstStyle/>
-          <a:p>
-            <a:pPr marL="0" indent="0">
-              <a:buNone/>
-            </a:pPr>
-            <a:r>
-              <a:rPr lang="en-US" sz="2850" b="1" dirty="0">
-                <a:solidFill>
-                  <a:schemeClr val="accent1"/>
-                </a:solidFill>
-              </a:rPr>
-              <a:t>Retry-safe</a:t>
-            </a:r>
-            <a:endParaRPr lang="en-US" sz="2850" dirty="0"/>
-          </a:p>
-        </p:txBody>
-      </p:sp>
-      <p:sp>
-        <p:nvSpPr>
-          <p:cNvPr id="11" name="Text 9"/>
-          <p:cNvSpPr txBox="1"/>
-          <p:nvPr/>
-        </p:nvSpPr>
-        <p:spPr>
-          <a:xfrm>
-            <a:off x="5806440" y="3767328"/>
-            <a:ext cx="2624328" cy="685800"/>
-          </a:xfrm>
-          <a:prstGeom prst="rect">
-            <a:avLst/>
-          </a:prstGeom>
-          <a:noFill/>
-          <a:ln/>
-        </p:spPr>
-        <p:txBody>
-          <a:bodyPr wrap="square" lIns="0" tIns="0" rIns="0" bIns="0" rtlCol="0" anchor="t"/>
-          <a:lstStyle/>
-          <a:p>
-            <a:pPr marL="0" indent="0">
-              <a:buNone/>
-            </a:pPr>
-            <a:r>
-              <a:rPr lang="en-US" sz="1300" dirty="0">
-                <a:solidFill>
-                  <a:schemeClr val="tx1"/>
-                </a:solidFill>
-              </a:rPr>
-              <a:t>Idempotency keys: a lost reply</a:t>
-            </a:r>
-            <a:endParaRPr lang="en-US" sz="1300" dirty="0"/>
-          </a:p>
-          <a:p>
-            <a:pPr marL="0" indent="0">
-              <a:buNone/>
-            </a:pPr>
-            <a:r>
-              <a:rPr lang="en-US" sz="1300" dirty="0">
-                <a:solidFill>
-                  <a:schemeClr val="tx1"/>
-                </a:solidFill>
-              </a:rPr>
-              <a:t>never pays twice</a:t>
-            </a:r>
-            <a:endParaRPr lang="en-US" sz="1300" dirty="0"/>
           </a:p>
         </p:txBody>
       </p:sp>
@@ -6362,6 +6841,811 @@
 </p:sld>
 </file>
 
+<file path=ppt/slides/slide17.xml><?xml version="1.0" encoding="utf-8"?>
+<p:sld xmlns:a="http://schemas.openxmlformats.org/drawingml/2006/main" xmlns:r="http://schemas.openxmlformats.org/officeDocument/2006/relationships" xmlns:p="http://schemas.openxmlformats.org/presentationml/2006/main">
+  <p:cSld name="Slide 13">
+    <p:spTree>
+      <p:nvGrpSpPr>
+        <p:cNvPr id="1" name=""/>
+        <p:cNvGrpSpPr/>
+        <p:nvPr/>
+      </p:nvGrpSpPr>
+      <p:grpSpPr>
+        <a:xfrm>
+          <a:off x="0" y="0"/>
+          <a:ext cx="0" cy="0"/>
+          <a:chOff x="0" y="0"/>
+          <a:chExt cx="0" cy="0"/>
+        </a:xfrm>
+      </p:grpSpPr>
+      <p:sp>
+        <p:nvSpPr>
+          <p:cNvPr id="2" name="Page number"/>
+          <p:cNvSpPr txBox="1"/>
+          <p:nvPr/>
+        </p:nvSpPr>
+        <p:spPr>
+          <a:xfrm>
+            <a:off x="7653528" y="4864608"/>
+            <a:ext cx="914400" cy="219456"/>
+          </a:xfrm>
+          <a:prstGeom prst="rect">
+            <a:avLst/>
+          </a:prstGeom>
+          <a:noFill/>
+          <a:ln/>
+        </p:spPr>
+        <p:txBody>
+          <a:bodyPr wrap="square" lIns="0" tIns="0" rIns="0" bIns="0" rtlCol="0" anchor="ctr"/>
+          <a:lstStyle/>
+          <a:p>
+            <a:pPr marL="0" indent="0" algn="r">
+              <a:buNone/>
+            </a:pPr>
+            <a:r>
+              <a:rPr lang="en-US" sz="1130" dirty="0">
+                <a:solidFill>
+                  <a:schemeClr val="tx2"/>
+                </a:solidFill>
+                <a:latin typeface="JetBrains Mono" pitchFamily="34" charset="0"/>
+                <a:ea typeface="JetBrains Mono" pitchFamily="34" charset="-122"/>
+                <a:cs typeface="JetBrains Mono" pitchFamily="34" charset="-120"/>
+              </a:rPr>
+              <a:t>15 / 16</a:t>
+            </a:r>
+            <a:endParaRPr lang="en-US" sz="1130" dirty="0"/>
+          </a:p>
+        </p:txBody>
+      </p:sp>
+      <p:sp>
+        <p:nvSpPr>
+          <p:cNvPr id="3" name="Text 3"/>
+          <p:cNvSpPr>
+            <a:spLocks noGrp="1"/>
+          </p:cNvSpPr>
+          <p:nvPr>
+            <p:ph type="title" idx="103" hasCustomPrompt="1"/>
+          </p:nvPr>
+        </p:nvSpPr>
+        <p:spPr>
+          <a:xfrm>
+            <a:off x="566928" y="566928"/>
+            <a:ext cx="8001000" cy="512064"/>
+          </a:xfrm>
+          <a:prstGeom prst="rect">
+            <a:avLst/>
+          </a:prstGeom>
+          <a:noFill/>
+          <a:ln/>
+        </p:spPr>
+        <p:txBody>
+          <a:bodyPr wrap="square" lIns="0" tIns="0" rIns="0" bIns="0" rtlCol="0" anchor="ctr"/>
+          <a:lstStyle/>
+          <a:p>
+            <a:pPr marL="0" indent="0" algn="l">
+              <a:buNone/>
+            </a:pPr>
+            <a:r>
+              <a:rPr lang="en-US" sz="2850" b="1" dirty="0">
+                <a:solidFill>
+                  <a:schemeClr val="tx1"/>
+                </a:solidFill>
+              </a:rPr>
+              <a:t>Try it yourself: six tabs, one engine</a:t>
+            </a:r>
+            <a:endParaRPr lang="en-US" sz="2850" dirty="0"/>
+          </a:p>
+        </p:txBody>
+      </p:sp>
+      <p:sp>
+        <p:nvSpPr>
+          <p:cNvPr id="101" name="URL"/>
+          <p:cNvSpPr txBox="1"/>
+          <p:nvPr/>
+        </p:nvSpPr>
+        <p:spPr>
+          <a:xfrm>
+            <a:off x="566928" y="1170000"/>
+            <a:ext cx="8010144" cy="400000"/>
+          </a:xfrm>
+          <a:prstGeom prst="rect">
+            <a:avLst/>
+          </a:prstGeom>
+          <a:noFill/>
+          <a:ln/>
+        </p:spPr>
+        <p:txBody>
+          <a:bodyPr wrap="square" lIns="0" tIns="0" rIns="0" bIns="0" rtlCol="0" anchor="ctr"/>
+          <a:lstStyle/>
+          <a:p>
+            <a:pPr marL="0" indent="0" algn="l">
+              <a:spcBef>
+                <a:spcPts val="0"/>
+              </a:spcBef>
+              <a:buNone/>
+            </a:pPr>
+            <a:r>
+              <a:rPr lang="en-US" sz="1400" dirty="0">
+                <a:solidFill>
+                  <a:schemeClr val="tx2"/>
+                </a:solidFill>
+              </a:rPr>
+              <a:t>Open  </a:t>
+            </a:r>
+            <a:r>
+              <a:rPr lang="en-US" sz="2200" b="1" dirty="0">
+                <a:solidFill>
+                  <a:schemeClr val="accent1"/>
+                </a:solidFill>
+                <a:latin typeface="JetBrains Mono"/>
+                <a:cs typeface="JetBrains Mono"/>
+                <a:hlinkClick r:id="rIdUrl"/>
+              </a:rPr>
+              <a:t>https://swarmsentinel.replit.app/</a:t>
+            </a:r>
+          </a:p>
+        </p:txBody>
+      </p:sp>
+      <p:sp>
+        <p:nvSpPr>
+          <p:cNvPr id="102" name="Tab bar"/>
+          <p:cNvSpPr/>
+          <p:nvPr/>
+        </p:nvSpPr>
+        <p:spPr>
+          <a:xfrm>
+            <a:off x="566928" y="1720000"/>
+            <a:ext cx="8010144" cy="440000"/>
+          </a:xfrm>
+          <a:prstGeom prst="rect">
+            <a:avLst/>
+          </a:prstGeom>
+          <a:solidFill>
+            <a:schemeClr val="bg2"/>
+          </a:solidFill>
+          <a:ln w="19050">
+            <a:solidFill>
+              <a:schemeClr val="accent1"/>
+            </a:solidFill>
+          </a:ln>
+        </p:spPr>
+        <p:txBody>
+          <a:bodyPr/>
+          <a:lstStyle/>
+          <a:p>
+            <a:endParaRPr lang="en-US"/>
+          </a:p>
+        </p:txBody>
+      </p:sp>
+      <p:sp>
+        <p:nvSpPr>
+          <p:cNvPr id="103" name="Active tab"/>
+          <p:cNvSpPr/>
+          <p:nvPr/>
+        </p:nvSpPr>
+        <p:spPr>
+          <a:xfrm>
+            <a:off x="612648" y="1774864"/>
+            <a:ext cx="1243584" cy="330272"/>
+          </a:xfrm>
+          <a:prstGeom prst="rect">
+            <a:avLst/>
+          </a:prstGeom>
+          <a:solidFill>
+            <a:schemeClr val="accent1">
+              <a:alpha val="18000"/>
+            </a:schemeClr>
+          </a:solidFill>
+          <a:ln>
+            <a:noFill/>
+          </a:ln>
+        </p:spPr>
+        <p:txBody>
+          <a:bodyPr/>
+          <a:lstStyle/>
+          <a:p>
+            <a:endParaRPr lang="en-US"/>
+          </a:p>
+        </p:txBody>
+      </p:sp>
+      <p:sp>
+        <p:nvSpPr>
+          <p:cNvPr id="104" name="Tab Normal Run"/>
+          <p:cNvSpPr txBox="1"/>
+          <p:nvPr/>
+        </p:nvSpPr>
+        <p:spPr>
+          <a:xfrm>
+            <a:off x="566928" y="1720000"/>
+            <a:ext cx="1335024" cy="440000"/>
+          </a:xfrm>
+          <a:prstGeom prst="rect">
+            <a:avLst/>
+          </a:prstGeom>
+          <a:noFill/>
+          <a:ln/>
+        </p:spPr>
+        <p:txBody>
+          <a:bodyPr wrap="square" lIns="0" tIns="0" rIns="0" bIns="0" rtlCol="0" anchor="ctr"/>
+          <a:lstStyle/>
+          <a:p>
+            <a:pPr marL="0" indent="0" algn="ctr">
+              <a:spcBef>
+                <a:spcPts val="0"/>
+              </a:spcBef>
+              <a:buNone/>
+            </a:pPr>
+            <a:r>
+              <a:rPr lang="en-US" sz="1200" b="1" dirty="0">
+                <a:solidFill>
+                  <a:schemeClr val="accent1"/>
+                </a:solidFill>
+              </a:rPr>
+              <a:t>Normal Run</a:t>
+            </a:r>
+          </a:p>
+        </p:txBody>
+      </p:sp>
+      <p:sp>
+        <p:nvSpPr>
+          <p:cNvPr id="105" name="Caption Normal Run"/>
+          <p:cNvSpPr txBox="1"/>
+          <p:nvPr/>
+        </p:nvSpPr>
+        <p:spPr>
+          <a:xfrm>
+            <a:off x="630936" y="2350000"/>
+            <a:ext cx="1207008" cy="1500000"/>
+          </a:xfrm>
+          <a:prstGeom prst="rect">
+            <a:avLst/>
+          </a:prstGeom>
+          <a:noFill/>
+          <a:ln/>
+        </p:spPr>
+        <p:txBody>
+          <a:bodyPr wrap="square" lIns="0" tIns="0" rIns="0" bIns="0" rtlCol="0" anchor="t"/>
+          <a:lstStyle/>
+          <a:p>
+            <a:pPr marL="0" indent="0" algn="ctr">
+              <a:spcBef>
+                <a:spcPts val="0"/>
+              </a:spcBef>
+              <a:buNone/>
+            </a:pPr>
+            <a:r>
+              <a:rPr lang="en-US" sz="1200" b="1" dirty="0">
+                <a:solidFill>
+                  <a:schemeClr val="accent1"/>
+                </a:solidFill>
+              </a:rPr>
+              <a:t>Baseline</a:t>
+            </a:r>
+          </a:p>
+          <a:p>
+            <a:pPr marL="0" indent="0" algn="ctr">
+              <a:spcBef>
+                <a:spcPts val="400"/>
+              </a:spcBef>
+              <a:buNone/>
+            </a:pPr>
+            <a:r>
+              <a:rPr lang="en-US" sz="1150" dirty="0">
+                <a:solidFill>
+                  <a:schemeClr val="tx1"/>
+                </a:solidFill>
+              </a:rPr>
+              <a:t>Three agents, distinct tasks. No alerts.</a:t>
+            </a:r>
+          </a:p>
+        </p:txBody>
+      </p:sp>
+      <p:sp>
+        <p:nvSpPr>
+          <p:cNvPr id="106" name="Tab Swarm Attack"/>
+          <p:cNvSpPr txBox="1"/>
+          <p:nvPr/>
+        </p:nvSpPr>
+        <p:spPr>
+          <a:xfrm>
+            <a:off x="1901952" y="1720000"/>
+            <a:ext cx="1335024" cy="440000"/>
+          </a:xfrm>
+          <a:prstGeom prst="rect">
+            <a:avLst/>
+          </a:prstGeom>
+          <a:noFill/>
+          <a:ln/>
+        </p:spPr>
+        <p:txBody>
+          <a:bodyPr wrap="square" lIns="0" tIns="0" rIns="0" bIns="0" rtlCol="0" anchor="ctr"/>
+          <a:lstStyle/>
+          <a:p>
+            <a:pPr marL="0" indent="0" algn="ctr">
+              <a:spcBef>
+                <a:spcPts val="0"/>
+              </a:spcBef>
+              <a:buNone/>
+            </a:pPr>
+            <a:r>
+              <a:rPr lang="en-US" sz="1200" dirty="0">
+                <a:solidFill>
+                  <a:schemeClr val="tx1"/>
+                </a:solidFill>
+              </a:rPr>
+              <a:t>Swarm Attack</a:t>
+            </a:r>
+          </a:p>
+        </p:txBody>
+      </p:sp>
+      <p:sp>
+        <p:nvSpPr>
+          <p:cNvPr id="107" name="Caption Swarm Attack"/>
+          <p:cNvSpPr txBox="1"/>
+          <p:nvPr/>
+        </p:nvSpPr>
+        <p:spPr>
+          <a:xfrm>
+            <a:off x="1965960" y="2350000"/>
+            <a:ext cx="1207008" cy="1500000"/>
+          </a:xfrm>
+          <a:prstGeom prst="rect">
+            <a:avLst/>
+          </a:prstGeom>
+          <a:noFill/>
+          <a:ln/>
+        </p:spPr>
+        <p:txBody>
+          <a:bodyPr wrap="square" lIns="0" tIns="0" rIns="0" bIns="0" rtlCol="0" anchor="t"/>
+          <a:lstStyle/>
+          <a:p>
+            <a:pPr marL="0" indent="0" algn="ctr">
+              <a:spcBef>
+                <a:spcPts val="0"/>
+              </a:spcBef>
+              <a:buNone/>
+            </a:pPr>
+            <a:r>
+              <a:rPr lang="en-US" sz="1200" b="1" dirty="0">
+                <a:solidFill>
+                  <a:schemeClr val="accent1"/>
+                </a:solidFill>
+              </a:rPr>
+              <a:t>Tripwires</a:t>
+            </a:r>
+          </a:p>
+          <a:p>
+            <a:pPr marL="0" indent="0" algn="ctr">
+              <a:spcBef>
+                <a:spcPts val="400"/>
+              </a:spcBef>
+              <a:buNone/>
+            </a:pPr>
+            <a:r>
+              <a:rPr lang="en-US" sz="1150" dirty="0">
+                <a:solidFill>
+                  <a:schemeClr val="tx1"/>
+                </a:solidFill>
+              </a:rPr>
+              <a:t>Echoed answers and fan-out. Branches revoked.</a:t>
+            </a:r>
+          </a:p>
+        </p:txBody>
+      </p:sp>
+      <p:sp>
+        <p:nvSpPr>
+          <p:cNvPr id="108" name="Tab Prompt Injection"/>
+          <p:cNvSpPr txBox="1"/>
+          <p:nvPr/>
+        </p:nvSpPr>
+        <p:spPr>
+          <a:xfrm>
+            <a:off x="3236976" y="1720000"/>
+            <a:ext cx="1335024" cy="440000"/>
+          </a:xfrm>
+          <a:prstGeom prst="rect">
+            <a:avLst/>
+          </a:prstGeom>
+          <a:noFill/>
+          <a:ln/>
+        </p:spPr>
+        <p:txBody>
+          <a:bodyPr wrap="square" lIns="0" tIns="0" rIns="0" bIns="0" rtlCol="0" anchor="ctr"/>
+          <a:lstStyle/>
+          <a:p>
+            <a:pPr marL="0" indent="0" algn="ctr">
+              <a:spcBef>
+                <a:spcPts val="0"/>
+              </a:spcBef>
+              <a:buNone/>
+            </a:pPr>
+            <a:r>
+              <a:rPr lang="en-US" sz="1200" dirty="0">
+                <a:solidFill>
+                  <a:schemeClr val="tx1"/>
+                </a:solidFill>
+              </a:rPr>
+              <a:t>Prompt Injection</a:t>
+            </a:r>
+          </a:p>
+        </p:txBody>
+      </p:sp>
+      <p:sp>
+        <p:nvSpPr>
+          <p:cNvPr id="109" name="Caption Prompt Injection"/>
+          <p:cNvSpPr txBox="1"/>
+          <p:nvPr/>
+        </p:nvSpPr>
+        <p:spPr>
+          <a:xfrm>
+            <a:off x="3300984" y="2350000"/>
+            <a:ext cx="1207008" cy="1500000"/>
+          </a:xfrm>
+          <a:prstGeom prst="rect">
+            <a:avLst/>
+          </a:prstGeom>
+          <a:noFill/>
+          <a:ln/>
+        </p:spPr>
+        <p:txBody>
+          <a:bodyPr wrap="square" lIns="0" tIns="0" rIns="0" bIns="0" rtlCol="0" anchor="t"/>
+          <a:lstStyle/>
+          <a:p>
+            <a:pPr marL="0" indent="0" algn="ctr">
+              <a:spcBef>
+                <a:spcPts val="0"/>
+              </a:spcBef>
+              <a:buNone/>
+            </a:pPr>
+            <a:r>
+              <a:rPr lang="en-US" sz="1200" b="1" dirty="0">
+                <a:solidFill>
+                  <a:schemeClr val="accent1"/>
+                </a:solidFill>
+              </a:rPr>
+              <a:t>Taint</a:t>
+            </a:r>
+          </a:p>
+          <a:p>
+            <a:pPr marL="0" indent="0" algn="ctr">
+              <a:spcBef>
+                <a:spcPts val="400"/>
+              </a:spcBef>
+              <a:buNone/>
+            </a:pPr>
+            <a:r>
+              <a:rPr lang="en-US" sz="1150" dirty="0">
+                <a:solidFill>
+                  <a:schemeClr val="tx1"/>
+                </a:solidFill>
+              </a:rPr>
+              <a:t>Poisoned invoice asks for $5,000. Zero moves.</a:t>
+            </a:r>
+          </a:p>
+        </p:txBody>
+      </p:sp>
+      <p:sp>
+        <p:nvSpPr>
+          <p:cNvPr id="110" name="Tab Runaway Loop"/>
+          <p:cNvSpPr txBox="1"/>
+          <p:nvPr/>
+        </p:nvSpPr>
+        <p:spPr>
+          <a:xfrm>
+            <a:off x="4572000" y="1720000"/>
+            <a:ext cx="1335024" cy="440000"/>
+          </a:xfrm>
+          <a:prstGeom prst="rect">
+            <a:avLst/>
+          </a:prstGeom>
+          <a:noFill/>
+          <a:ln/>
+        </p:spPr>
+        <p:txBody>
+          <a:bodyPr wrap="square" lIns="0" tIns="0" rIns="0" bIns="0" rtlCol="0" anchor="ctr"/>
+          <a:lstStyle/>
+          <a:p>
+            <a:pPr marL="0" indent="0" algn="ctr">
+              <a:spcBef>
+                <a:spcPts val="0"/>
+              </a:spcBef>
+              <a:buNone/>
+            </a:pPr>
+            <a:r>
+              <a:rPr lang="en-US" sz="1200" dirty="0">
+                <a:solidFill>
+                  <a:schemeClr val="tx1"/>
+                </a:solidFill>
+              </a:rPr>
+              <a:t>Runaway Loop</a:t>
+            </a:r>
+          </a:p>
+        </p:txBody>
+      </p:sp>
+      <p:sp>
+        <p:nvSpPr>
+          <p:cNvPr id="111" name="Caption Runaway Loop"/>
+          <p:cNvSpPr txBox="1"/>
+          <p:nvPr/>
+        </p:nvSpPr>
+        <p:spPr>
+          <a:xfrm>
+            <a:off x="4636008" y="2350000"/>
+            <a:ext cx="1207008" cy="1500000"/>
+          </a:xfrm>
+          <a:prstGeom prst="rect">
+            <a:avLst/>
+          </a:prstGeom>
+          <a:noFill/>
+          <a:ln/>
+        </p:spPr>
+        <p:txBody>
+          <a:bodyPr wrap="square" lIns="0" tIns="0" rIns="0" bIns="0" rtlCol="0" anchor="t"/>
+          <a:lstStyle/>
+          <a:p>
+            <a:pPr marL="0" indent="0" algn="ctr">
+              <a:spcBef>
+                <a:spcPts val="0"/>
+              </a:spcBef>
+              <a:buNone/>
+            </a:pPr>
+            <a:r>
+              <a:rPr lang="en-US" sz="1200" b="1" dirty="0">
+                <a:solidFill>
+                  <a:schemeClr val="accent1"/>
+                </a:solidFill>
+              </a:rPr>
+              <a:t>No attacker</a:t>
+            </a:r>
+          </a:p>
+          <a:p>
+            <a:pPr marL="0" indent="0" algn="ctr">
+              <a:spcBef>
+                <a:spcPts val="400"/>
+              </a:spcBef>
+              <a:buNone/>
+            </a:pPr>
+            <a:r>
+              <a:rPr lang="en-US" sz="1150" dirty="0">
+                <a:solidFill>
+                  <a:schemeClr val="tx1"/>
+                </a:solidFill>
+              </a:rPr>
+              <a:t>Loop that never converges, 22 retries. Throttled.</a:t>
+            </a:r>
+          </a:p>
+        </p:txBody>
+      </p:sp>
+      <p:sp>
+        <p:nvSpPr>
+          <p:cNvPr id="112" name="Tab AI Village"/>
+          <p:cNvSpPr txBox="1"/>
+          <p:nvPr/>
+        </p:nvSpPr>
+        <p:spPr>
+          <a:xfrm>
+            <a:off x="5907024" y="1720000"/>
+            <a:ext cx="1335024" cy="440000"/>
+          </a:xfrm>
+          <a:prstGeom prst="rect">
+            <a:avLst/>
+          </a:prstGeom>
+          <a:noFill/>
+          <a:ln/>
+        </p:spPr>
+        <p:txBody>
+          <a:bodyPr wrap="square" lIns="0" tIns="0" rIns="0" bIns="0" rtlCol="0" anchor="ctr"/>
+          <a:lstStyle/>
+          <a:p>
+            <a:pPr marL="0" indent="0" algn="ctr">
+              <a:spcBef>
+                <a:spcPts val="0"/>
+              </a:spcBef>
+              <a:buNone/>
+            </a:pPr>
+            <a:r>
+              <a:rPr lang="en-US" sz="1200" dirty="0">
+                <a:solidFill>
+                  <a:schemeClr val="tx2"/>
+                </a:solidFill>
+              </a:rPr>
+              <a:t>AI Village</a:t>
+            </a:r>
+          </a:p>
+        </p:txBody>
+      </p:sp>
+      <p:sp>
+        <p:nvSpPr>
+          <p:cNvPr id="113" name="Caption AI Village"/>
+          <p:cNvSpPr txBox="1"/>
+          <p:nvPr/>
+        </p:nvSpPr>
+        <p:spPr>
+          <a:xfrm>
+            <a:off x="5971032" y="2350000"/>
+            <a:ext cx="1207008" cy="1500000"/>
+          </a:xfrm>
+          <a:prstGeom prst="rect">
+            <a:avLst/>
+          </a:prstGeom>
+          <a:noFill/>
+          <a:ln/>
+        </p:spPr>
+        <p:txBody>
+          <a:bodyPr wrap="square" lIns="0" tIns="0" rIns="0" bIns="0" rtlCol="0" anchor="t"/>
+          <a:lstStyle/>
+          <a:p>
+            <a:pPr marL="0" indent="0" algn="ctr">
+              <a:spcBef>
+                <a:spcPts val="0"/>
+              </a:spcBef>
+              <a:buNone/>
+            </a:pPr>
+            <a:r>
+              <a:rPr lang="en-US" sz="1200" b="1" dirty="0">
+                <a:solidFill>
+                  <a:schemeClr val="tx2"/>
+                </a:solidFill>
+              </a:rPr>
+              <a:t>Real data</a:t>
+            </a:r>
+          </a:p>
+          <a:p>
+            <a:pPr marL="0" indent="0" algn="ctr">
+              <a:spcBef>
+                <a:spcPts val="400"/>
+              </a:spcBef>
+              <a:buNone/>
+            </a:pPr>
+            <a:r>
+              <a:rPr lang="en-US" sz="1150" dirty="0">
+                <a:solidFill>
+                  <a:schemeClr val="tx1"/>
+                </a:solidFill>
+              </a:rPr>
+              <a:t>Report-only replay. Approved accounts only.</a:t>
+            </a:r>
+          </a:p>
+        </p:txBody>
+      </p:sp>
+      <p:sp>
+        <p:nvSpPr>
+          <p:cNvPr id="114" name="Tab Live"/>
+          <p:cNvSpPr txBox="1"/>
+          <p:nvPr/>
+        </p:nvSpPr>
+        <p:spPr>
+          <a:xfrm>
+            <a:off x="7242048" y="1720000"/>
+            <a:ext cx="1335024" cy="440000"/>
+          </a:xfrm>
+          <a:prstGeom prst="rect">
+            <a:avLst/>
+          </a:prstGeom>
+          <a:noFill/>
+          <a:ln/>
+        </p:spPr>
+        <p:txBody>
+          <a:bodyPr wrap="square" lIns="0" tIns="0" rIns="0" bIns="0" rtlCol="0" anchor="ctr"/>
+          <a:lstStyle/>
+          <a:p>
+            <a:pPr marL="0" indent="0" algn="ctr">
+              <a:spcBef>
+                <a:spcPts val="0"/>
+              </a:spcBef>
+              <a:buNone/>
+            </a:pPr>
+            <a:r>
+              <a:rPr lang="en-US" sz="1200" dirty="0">
+                <a:solidFill>
+                  <a:schemeClr val="tx1"/>
+                </a:solidFill>
+              </a:rPr>
+              <a:t>Live</a:t>
+            </a:r>
+          </a:p>
+        </p:txBody>
+      </p:sp>
+      <p:sp>
+        <p:nvSpPr>
+          <p:cNvPr id="115" name="Caption Live"/>
+          <p:cNvSpPr txBox="1"/>
+          <p:nvPr/>
+        </p:nvSpPr>
+        <p:spPr>
+          <a:xfrm>
+            <a:off x="7306056" y="2350000"/>
+            <a:ext cx="1207008" cy="1500000"/>
+          </a:xfrm>
+          <a:prstGeom prst="rect">
+            <a:avLst/>
+          </a:prstGeom>
+          <a:noFill/>
+          <a:ln/>
+        </p:spPr>
+        <p:txBody>
+          <a:bodyPr wrap="square" lIns="0" tIns="0" rIns="0" bIns="0" rtlCol="0" anchor="t"/>
+          <a:lstStyle/>
+          <a:p>
+            <a:pPr marL="0" indent="0" algn="ctr">
+              <a:spcBef>
+                <a:spcPts val="0"/>
+              </a:spcBef>
+              <a:buNone/>
+            </a:pPr>
+            <a:r>
+              <a:rPr lang="en-US" sz="1200" b="1" dirty="0">
+                <a:solidFill>
+                  <a:schemeClr val="accent1"/>
+                </a:solidFill>
+              </a:rPr>
+              <a:t>Real agents</a:t>
+            </a:r>
+          </a:p>
+          <a:p>
+            <a:pPr marL="0" indent="0" algn="ctr">
+              <a:spcBef>
+                <a:spcPts val="400"/>
+              </a:spcBef>
+              <a:buNone/>
+            </a:pPr>
+            <a:r>
+              <a:rPr lang="en-US" sz="1150" dirty="0">
+                <a:solidFill>
+                  <a:schemeClr val="tx1"/>
+                </a:solidFill>
+              </a:rPr>
+              <a:t>Decisions stream in as they happen.</a:t>
+            </a:r>
+          </a:p>
+        </p:txBody>
+      </p:sp>
+      <p:sp>
+        <p:nvSpPr>
+          <p:cNvPr id="116" name="Footnote"/>
+          <p:cNvSpPr txBox="1"/>
+          <p:nvPr/>
+        </p:nvSpPr>
+        <p:spPr>
+          <a:xfrm>
+            <a:off x="566928" y="3800000"/>
+            <a:ext cx="8010144" cy="420000"/>
+          </a:xfrm>
+          <a:prstGeom prst="rect">
+            <a:avLst/>
+          </a:prstGeom>
+          <a:noFill/>
+          <a:ln/>
+        </p:spPr>
+        <p:txBody>
+          <a:bodyPr wrap="square" lIns="0" tIns="0" rIns="0" bIns="0" rtlCol="0" anchor="b"/>
+          <a:lstStyle/>
+          <a:p>
+            <a:pPr marL="0" indent="0" algn="l">
+              <a:spcBef>
+                <a:spcPts val="0"/>
+              </a:spcBef>
+              <a:buNone/>
+            </a:pPr>
+            <a:r>
+              <a:rPr lang="en-US" sz="1150" dirty="0">
+                <a:solidFill>
+                  <a:schemeClr val="tx2"/>
+                </a:solidFill>
+              </a:rPr>
+              <a:t>Synthetic tabs run the gateway in enforce mode. AI Village is dimmed unless your account is approved; judges can rebuild it locally (docs/JUDGES.md).</a:t>
+            </a:r>
+          </a:p>
+        </p:txBody>
+      </p:sp>
+    </p:spTree>
+  </p:cSld>
+  <p:clrMapOvr>
+    <a:masterClrMapping/>
+  </p:clrMapOvr>
+</p:sld>
+</file>
+
 <file path=ppt/slides/slide2.xml><?xml version="1.0" encoding="utf-8"?>
 <p:sld xmlns:a="http://schemas.openxmlformats.org/drawingml/2006/main" xmlns:r="http://schemas.openxmlformats.org/officeDocument/2006/relationships" xmlns:p="http://schemas.openxmlformats.org/presentationml/2006/main">
   <p:cSld name="Slide 2">
@@ -6412,7 +7696,7 @@
                 <a:ea typeface="JetBrains Mono" pitchFamily="34" charset="-122"/>
                 <a:cs typeface="JetBrains Mono" pitchFamily="34" charset="-120"/>
               </a:rPr>
-              <a:t>02 / 15</a:t>
+              <a:t>02 / 16</a:t>
             </a:r>
             <a:endParaRPr lang="en-US" sz="1130" dirty="0"/>
           </a:p>
@@ -6912,7 +8196,7 @@
                 <a:ea typeface="JetBrains Mono" pitchFamily="34" charset="-122"/>
                 <a:cs typeface="JetBrains Mono" pitchFamily="34" charset="-120"/>
               </a:rPr>
-              <a:t>03 / 15</a:t>
+              <a:t>03 / 16</a:t>
             </a:r>
             <a:endParaRPr lang="en-US" sz="1130" dirty="0"/>
           </a:p>
@@ -8026,7 +9310,7 @@
                 <a:ea typeface="JetBrains Mono" pitchFamily="34" charset="-122"/>
                 <a:cs typeface="JetBrains Mono" pitchFamily="34" charset="-120"/>
               </a:rPr>
-              <a:t>04 / 15</a:t>
+              <a:t>04 / 16</a:t>
             </a:r>
             <a:endParaRPr lang="en-US" sz="1130" dirty="0"/>
           </a:p>
@@ -10078,7 +11362,7 @@
                 <a:ea typeface="JetBrains Mono" pitchFamily="34" charset="-122"/>
                 <a:cs typeface="JetBrains Mono" pitchFamily="34" charset="-120"/>
               </a:rPr>
-              <a:t>05 / 15</a:t>
+              <a:t>05 / 16</a:t>
             </a:r>
             <a:endParaRPr lang="en-US" sz="1130" dirty="0"/>
           </a:p>
@@ -10866,7 +12150,7 @@
                 <a:ea typeface="JetBrains Mono" pitchFamily="34" charset="-122"/>
                 <a:cs typeface="JetBrains Mono" pitchFamily="34" charset="-120"/>
               </a:rPr>
-              <a:t>06 / 15</a:t>
+              <a:t>06 / 16</a:t>
             </a:r>
             <a:endParaRPr lang="en-US" sz="1130" dirty="0"/>
           </a:p>
@@ -11951,7 +13235,7 @@
                 <a:ea typeface="JetBrains Mono" pitchFamily="34" charset="-122"/>
                 <a:cs typeface="JetBrains Mono" pitchFamily="34" charset="-120"/>
               </a:rPr>
-              <a:t>07 / 15</a:t>
+              <a:t>07 / 16</a:t>
             </a:r>
             <a:endParaRPr lang="en-US" sz="1130" dirty="0"/>
           </a:p>
@@ -13617,7 +14901,7 @@
                 <a:ea typeface="JetBrains Mono" pitchFamily="34" charset="-122"/>
                 <a:cs typeface="JetBrains Mono" pitchFamily="34" charset="-120"/>
               </a:rPr>
-              <a:t>08 / 15</a:t>
+              <a:t>08 / 16</a:t>
             </a:r>
             <a:endParaRPr lang="en-US" sz="1130" dirty="0"/>
           </a:p>
@@ -14188,7 +15472,7 @@
                 <a:ea typeface="JetBrains Mono" pitchFamily="34" charset="-122"/>
                 <a:cs typeface="JetBrains Mono" pitchFamily="34" charset="-120"/>
               </a:rPr>
-              <a:t>09 / 15</a:t>
+              <a:t>09 / 16</a:t>
             </a:r>
             <a:endParaRPr lang="en-US" sz="1130" dirty="0"/>
           </a:p>

</xml_diff>

<commit_message>
Add TAISAP manuscript, analysis scripts and combined decks
- docs/source-materials/taisap-2026: double-anonymous ACM TAISAP submission
  (docx and PDF preview, 35 pages), the scripts that produce every table and
  figure, aggregate results only, every policy used for a result, figures and
  submission notes. AI Village data is not included.
- SwarmSentinel + SwarmSheriff security briefing and conference talk decks;
  v3 deck gains the MCP proxy slide.
</commit_message>
<xml_diff>
--- a/docs/source-materials/SwarmSentinel-v3---Live-Containment.pptx
+++ b/docs/source-materials/SwarmSentinel-v3---Live-Containment.pptx
@@ -20,6 +20,7 @@
     <p:sldId id="265" r:id="rId11"/>
     <p:sldId id="266" r:id="rId12"/>
     <p:sldId id="270" r:id="rId13"/>
+    <p:sldId id="273" r:id="rId24"/>
     <p:sldId id="267" r:id="rId14"/>
     <p:sldId id="268" r:id="rId15"/>
     <p:sldId id="272" r:id="rId16"/>
@@ -1254,13 +1255,13 @@
           <a:p>
             <a:r>
               <a:rPr lang="en-US" dirty="0"/>
-              <a:t>- Not yet: OS isolation, and wrapped tools can be bypassed.</a:t>
+              <a:t>- Not yet: OS isolation, and wrapped SDK tools can still be bypassed.</a:t>
             </a:r>
           </a:p>
           <a:p>
             <a:r>
               <a:rPr lang="en-US" dirty="0"/>
-              <a:t>- Next: an MCP proxy in front of every tool.</a:t>
+              <a:t>- Next: a container recipe so the MCP proxy is the only route.</a:t>
             </a:r>
           </a:p>
           <a:p>
@@ -1272,7 +1273,7 @@
           <a:p>
             <a:r>
               <a:rPr lang="en-US" dirty="0"/>
-              <a:t>What this is not, yet. Tools you wrap with our guard are cooperative: an agent that calls them directly is not stopped. Only the four engine-owned demo tools are truly behind the gateway. There is no container or operating-system isolation, and sessions live in memory, so an engine restart loses them. In the real-agent runs the models are instructed to probe the guard, so those runs prove the guard holds, not that a model was fooled spontaneously. Thresholds were tuned on one dataset. The roadmap answers each: an MCP proxy so every tool sits behind the gateway, process or container isolation, durable sessions, taint through shared files, and server-assigned policies beyond the demo.</a:t>
+              <a:t>What this is not, yet. Tools wrapped with the SDK guard stay cooperative. The MCP proxy removes that for MCP traffic, but only when the agent has no other route to side effects, and there is no container or operating-system isolation in the repo to guarantee that. Content inspection is pattern-based, so paraphrased or encoded injections get through. Thresholds were tuned on one dataset. Sessions can now be journaled to SQLite and survive a restart. Next: a container recipe with egress only to the engine plus bypass tests, agent-to-agent messages through the proxy so taint propagates there too, taint through shared files, and budgets in tokens or cost rather than step counts.</a:t>
             </a:r>
           </a:p>
         </p:txBody>
@@ -1616,6 +1617,117 @@
             <a:fld id="{F7021451-1387-4CA6-816F-3879F97B5CBC}" type="slidenum">
               <a:rPr lang="en-US"/>
               <a:t>17</a:t>
+            </a:fld>
+            <a:endParaRPr lang="en-US"/>
+          </a:p>
+        </p:txBody>
+      </p:sp>
+    </p:spTree>
+    <p:extLst>
+      <p:ext uri="{BB962C8B-B14F-4D97-AF65-F5344CB8AC3E}">
+        <p14:creationId xmlns:p14="http://schemas.microsoft.com/office/powerpoint/2010/main" val="1024086991"/>
+      </p:ext>
+    </p:extLst>
+  </p:cSld>
+  <p:clrMapOvr>
+    <a:masterClrMapping/>
+  </p:clrMapOvr>
+</p:notes>
+</file>
+
+<file path=ppt/notesSlides/notesSlide18.xml><?xml version="1.0" encoding="utf-8"?>
+<p:notes xmlns:a="http://schemas.openxmlformats.org/drawingml/2006/main" xmlns:r="http://schemas.openxmlformats.org/officeDocument/2006/relationships" xmlns:p="http://schemas.openxmlformats.org/presentationml/2006/main">
+  <p:cSld>
+    <p:spTree>
+      <p:nvGrpSpPr>
+        <p:cNvPr id="1" name=""/>
+        <p:cNvGrpSpPr/>
+        <p:nvPr/>
+      </p:nvGrpSpPr>
+      <p:grpSpPr>
+        <a:xfrm>
+          <a:off x="0" y="0"/>
+          <a:ext cx="0" cy="0"/>
+          <a:chOff x="0" y="0"/>
+          <a:chExt cx="0" cy="0"/>
+        </a:xfrm>
+      </p:grpSpPr>
+      <p:sp>
+        <p:nvSpPr>
+          <p:cNvPr id="2" name="Slide Image Placeholder 1"/>
+          <p:cNvSpPr>
+            <a:spLocks noGrp="1" noRot="1" noChangeAspect="1"/>
+          </p:cNvSpPr>
+          <p:nvPr>
+            <p:ph type="sldImg"/>
+          </p:nvPr>
+        </p:nvSpPr>
+        <p:spPr/>
+      </p:sp>
+      <p:sp>
+        <p:nvSpPr>
+          <p:cNvPr id="3" name="Notes Placeholder 2"/>
+          <p:cNvSpPr>
+            <a:spLocks noGrp="1"/>
+          </p:cNvSpPr>
+          <p:nvPr>
+            <p:ph type="body" idx="1"/>
+          </p:nvPr>
+        </p:nvSpPr>
+        <p:spPr/>
+        <p:txBody>
+          <a:bodyPr/>
+          <a:lstStyle/>
+          <a:p>
+            <a:r>
+              <a:rPr lang="en-US" b="1" dirty="0"/>
+              <a:t>SAY (~15 s):</a:t>
+            </a:r>
+          </a:p>
+          <a:p>
+            <a:r>
+              <a:rPr lang="en-US" dirty="0"/>
+              <a:t>- The agent no longer has to cooperate: the engine holds the only route to its tools.</a:t>
+            </a:r>
+          </a:p>
+          <a:p>
+            <a:r>
+              <a:rPr lang="en-US" dirty="0"/>
+              <a:t>- A refused call never reaches the server.</a:t>
+            </a:r>
+          </a:p>
+          <a:p>
+            <a:r>
+              <a:rPr lang="en-US" b="1" dirty="0"/>
+              <a:t>Full notes:</a:t>
+            </a:r>
+          </a:p>
+          <a:p>
+            <a:r>
+              <a:rPr lang="en-US" dirty="0"/>
+              <a:t>Up to now the guard was cooperative: an agent that ignored a refusal could still call its tool directly. MCP proxy mode closes that for MCP traffic. The engine hosts an MCP endpoint and issues each agent a credential when it is spawned, so identity and lineage come from the engine, not the agent. What each tool means, read or write, untrusted output, network argument, comes from the policy file; tools the policy does not declare are hidden. Every call runs through the same Algorithm 1 checks, then content inspection for secrets, PII and injection markers. Only an allowed call reaches the downstream MCP server, which the engine launches itself, and the engine records the outcome. Claude Agent SDK, LangChain and Claude Code connect through adapters. The honest condition: this binds only if the proxy is the agent's sole route to side effects. That is a deployment property; the container recipe is the next phase.</a:t>
+            </a:r>
+          </a:p>
+        </p:txBody>
+      </p:sp>
+      <p:sp>
+        <p:nvSpPr>
+          <p:cNvPr id="4" name="Slide Number Placeholder 3"/>
+          <p:cNvSpPr>
+            <a:spLocks noGrp="1"/>
+          </p:cNvSpPr>
+          <p:nvPr>
+            <p:ph type="sldNum" sz="quarter" idx="10"/>
+          </p:nvPr>
+        </p:nvSpPr>
+        <p:spPr/>
+        <p:txBody>
+          <a:bodyPr/>
+          <a:lstStyle/>
+          <a:p>
+            <a:fld id="{F7021451-1387-4CA6-816F-3879F97B5CBC}" type="slidenum">
+              <a:rPr lang="en-US"/>
+              <a:t>13</a:t>
             </a:fld>
             <a:endParaRPr lang="en-US"/>
           </a:p>
@@ -3325,7 +3437,7 @@
                 <a:ea typeface="JetBrains Mono" pitchFamily="34" charset="-122"/>
                 <a:cs typeface="JetBrains Mono" pitchFamily="34" charset="-120"/>
               </a:rPr>
-              <a:t>01 / 16</a:t>
+              <a:t>01 / 17</a:t>
             </a:r>
             <a:endParaRPr lang="en-US" sz="1130" dirty="0"/>
           </a:p>
@@ -3723,7 +3835,7 @@
                 <a:ea typeface="JetBrains Mono" pitchFamily="34" charset="-122"/>
                 <a:cs typeface="JetBrains Mono" pitchFamily="34" charset="-120"/>
               </a:rPr>
-              <a:t>10 / 16</a:t>
+              <a:t>10 / 17</a:t>
             </a:r>
             <a:endParaRPr lang="en-US" sz="1130" dirty="0"/>
           </a:p>
@@ -3993,7 +4105,7 @@
                 <a:ea typeface="JetBrains Mono" pitchFamily="34" charset="-122"/>
                 <a:cs typeface="JetBrains Mono" pitchFamily="34" charset="-120"/>
               </a:rPr>
-              <a:t>11 / 16</a:t>
+              <a:t>11 / 17</a:t>
             </a:r>
             <a:endParaRPr lang="en-US" sz="1130" dirty="0"/>
           </a:p>
@@ -4585,7 +4697,7 @@
                 <a:ea typeface="JetBrains Mono" pitchFamily="34" charset="-122"/>
                 <a:cs typeface="JetBrains Mono" pitchFamily="34" charset="-120"/>
               </a:rPr>
-              <a:t>12 / 16</a:t>
+              <a:t>12 / 17</a:t>
             </a:r>
             <a:endParaRPr lang="en-US" sz="1130" dirty="0"/>
           </a:p>
@@ -5182,7 +5294,7 @@
                 <a:ea typeface="JetBrains Mono" pitchFamily="34" charset="-122"/>
                 <a:cs typeface="JetBrains Mono" pitchFamily="34" charset="-120"/>
               </a:rPr>
-              <a:t>13 / 16</a:t>
+              <a:t>14 / 17</a:t>
             </a:r>
             <a:endParaRPr lang="en-US" sz="1130" dirty="0"/>
           </a:p>
@@ -5541,7 +5653,7 @@
                 <a:ea typeface="JetBrains Mono" pitchFamily="34" charset="-122"/>
                 <a:cs typeface="JetBrains Mono" pitchFamily="34" charset="-120"/>
               </a:rPr>
-              <a:t>14 / 16</a:t>
+              <a:t>15 / 17</a:t>
             </a:r>
             <a:endParaRPr lang="en-US" sz="1130" dirty="0"/>
           </a:p>
@@ -5691,7 +5803,7 @@
                   <a:schemeClr val="tx1"/>
                 </a:solidFill>
               </a:rPr>
-              <a:t>Wrapped tools are cooperative; only engine-owned demo tools are unbypassable</a:t>
+              <a:t>Wrapped SDK tools stay cooperative; the MCP proxy binds only agents with no other tool route</a:t>
             </a:r>
             <a:endParaRPr lang="en-US" sz="1400" dirty="0"/>
           </a:p>
@@ -5712,7 +5824,7 @@
                   <a:schemeClr val="tx1"/>
                 </a:solidFill>
               </a:rPr>
-              <a:t>No container or operating-system isolation</a:t>
+              <a:t>No container or operating-system isolation yet</a:t>
             </a:r>
             <a:endParaRPr lang="en-US" sz="1400" dirty="0"/>
           </a:p>
@@ -5733,7 +5845,7 @@
                   <a:schemeClr val="tx1"/>
                 </a:solidFill>
               </a:rPr>
-              <a:t>Real-agent runs instruct the model to probe the guard</a:t>
+              <a:t>Content inspection is pattern-based: paraphrased injections slip through</a:t>
             </a:r>
             <a:endParaRPr lang="en-US" sz="1400" dirty="0"/>
           </a:p>
@@ -5864,7 +5976,7 @@
                   <a:schemeClr val="tx1"/>
                 </a:solidFill>
               </a:rPr>
-              <a:t>MCP proxy so any tool sits behind the gateway</a:t>
+              <a:t>Container recipe with egress only to the engine, plus bypass tests</a:t>
             </a:r>
             <a:endParaRPr lang="en-US" sz="1400" dirty="0"/>
           </a:p>
@@ -5885,7 +5997,7 @@
                   <a:schemeClr val="tx1"/>
                 </a:solidFill>
               </a:rPr>
-              <a:t>Container or separate-user isolation</a:t>
+              <a:t>Agent-to-agent messages through the proxy, so taint propagates</a:t>
             </a:r>
             <a:endParaRPr lang="en-US" sz="1400" dirty="0"/>
           </a:p>
@@ -5927,7 +6039,7 @@
                   <a:schemeClr val="tx1"/>
                 </a:solidFill>
               </a:rPr>
-              <a:t>Server-assigned policies beyond the demo</a:t>
+              <a:t>Token or cost budgets, not only step counts</a:t>
             </a:r>
             <a:endParaRPr lang="en-US" sz="1400" dirty="0"/>
           </a:p>
@@ -5991,7 +6103,7 @@
                 <a:ea typeface="JetBrains Mono" pitchFamily="34" charset="-122"/>
                 <a:cs typeface="JetBrains Mono" pitchFamily="34" charset="-120"/>
               </a:rPr>
-              <a:t>15 / 16</a:t>
+              <a:t>16 / 17</a:t>
             </a:r>
             <a:endParaRPr lang="en-US" sz="1130" dirty="0"/>
           </a:p>
@@ -6830,7 +6942,7 @@
                 <a:ea typeface="JetBrains Mono" pitchFamily="34" charset="-122"/>
                 <a:cs typeface="JetBrains Mono" pitchFamily="34" charset="-120"/>
               </a:rPr>
-              <a:t>16 / 16</a:t>
+              <a:t>17 / 17</a:t>
             </a:r>
             <a:endParaRPr lang="en-US" sz="1130" dirty="0"/>
           </a:p>
@@ -7869,6 +7981,798 @@
 </p:sld>
 </file>
 
+<file path=ppt/slides/slide18.xml><?xml version="1.0" encoding="utf-8"?>
+<p:sld xmlns:a="http://schemas.openxmlformats.org/drawingml/2006/main" xmlns:r="http://schemas.openxmlformats.org/officeDocument/2006/relationships" xmlns:p="http://schemas.openxmlformats.org/presentationml/2006/main">
+  <p:cSld name="Slide 5">
+    <p:spTree>
+      <p:nvGrpSpPr>
+        <p:cNvPr id="1" name=""/>
+        <p:cNvGrpSpPr/>
+        <p:nvPr/>
+      </p:nvGrpSpPr>
+      <p:grpSpPr>
+        <a:xfrm>
+          <a:off x="0" y="0"/>
+          <a:ext cx="0" cy="0"/>
+          <a:chOff x="0" y="0"/>
+          <a:chExt cx="0" cy="0"/>
+        </a:xfrm>
+      </p:grpSpPr>
+      <p:sp>
+        <p:nvSpPr>
+          <p:cNvPr id="2" name="Page number"/>
+          <p:cNvSpPr txBox="1"/>
+          <p:nvPr/>
+        </p:nvSpPr>
+        <p:spPr>
+          <a:xfrm>
+            <a:off x="7653528" y="4864608"/>
+            <a:ext cx="914400" cy="219456"/>
+          </a:xfrm>
+          <a:prstGeom prst="rect">
+            <a:avLst/>
+          </a:prstGeom>
+          <a:noFill/>
+          <a:ln/>
+        </p:spPr>
+        <p:txBody>
+          <a:bodyPr wrap="square" lIns="0" tIns="0" rIns="0" bIns="0" rtlCol="0" anchor="ctr"/>
+          <a:lstStyle/>
+          <a:p>
+            <a:pPr marL="0" indent="0" algn="r">
+              <a:buNone/>
+            </a:pPr>
+            <a:r>
+              <a:rPr lang="en-US" sz="1130" dirty="0">
+                <a:solidFill>
+                  <a:schemeClr val="tx2"/>
+                </a:solidFill>
+                <a:latin typeface="JetBrains Mono" pitchFamily="34" charset="0"/>
+                <a:ea typeface="JetBrains Mono" pitchFamily="34" charset="-122"/>
+                <a:cs typeface="JetBrains Mono" pitchFamily="34" charset="-120"/>
+              </a:rPr>
+              <a:t>13 / 17</a:t>
+            </a:r>
+            <a:endParaRPr lang="en-US" sz="1130" dirty="0"/>
+          </a:p>
+        </p:txBody>
+      </p:sp>
+      <p:sp>
+        <p:nvSpPr>
+          <p:cNvPr id="3" name="Text 3"/>
+          <p:cNvSpPr>
+            <a:spLocks noGrp="1"/>
+          </p:cNvSpPr>
+          <p:nvPr>
+            <p:ph type="title" idx="103" hasCustomPrompt="1"/>
+          </p:nvPr>
+        </p:nvSpPr>
+        <p:spPr>
+          <a:xfrm>
+            <a:off x="566928" y="566928"/>
+            <a:ext cx="8001000" cy="512064"/>
+          </a:xfrm>
+          <a:prstGeom prst="rect">
+            <a:avLst/>
+          </a:prstGeom>
+          <a:noFill/>
+          <a:ln/>
+        </p:spPr>
+        <p:txBody>
+          <a:bodyPr wrap="square" lIns="0" tIns="0" rIns="0" bIns="0" rtlCol="0" anchor="ctr"/>
+          <a:lstStyle/>
+          <a:p>
+            <a:pPr marL="0" indent="0" algn="l">
+              <a:buNone/>
+            </a:pPr>
+            <a:r>
+              <a:rPr lang="en-US" sz="2850" b="1" dirty="0">
+                <a:solidFill>
+                  <a:schemeClr val="tx1"/>
+                </a:solidFill>
+              </a:rPr>
+              <a:t>MCP proxy: the engine owns the tool route</a:t>
+            </a:r>
+            <a:endParaRPr lang="en-US" sz="2850" dirty="0"/>
+          </a:p>
+        </p:txBody>
+      </p:sp>
+      <p:sp>
+        <p:nvSpPr>
+          <p:cNvPr id="4" name="Box Agent + guard"/>
+          <p:cNvSpPr/>
+          <p:nvPr/>
+        </p:nvSpPr>
+        <p:spPr>
+          <a:xfrm>
+            <a:off x="566928" y="1371600"/>
+            <a:ext cx="1417320" cy="457200"/>
+          </a:xfrm>
+          <a:prstGeom prst="rect">
+            <a:avLst/>
+          </a:prstGeom>
+          <a:solidFill>
+            <a:schemeClr val="bg2"/>
+          </a:solidFill>
+          <a:ln/>
+        </p:spPr>
+        <p:txBody>
+          <a:bodyPr/>
+          <a:lstStyle/>
+          <a:p>
+            <a:endParaRPr lang="en-US"/>
+          </a:p>
+        </p:txBody>
+      </p:sp>
+      <p:sp>
+        <p:nvSpPr>
+          <p:cNvPr id="5" name="Text 3"/>
+          <p:cNvSpPr txBox="1"/>
+          <p:nvPr/>
+        </p:nvSpPr>
+        <p:spPr>
+          <a:xfrm>
+            <a:off x="566928" y="1371600"/>
+            <a:ext cx="1417320" cy="457200"/>
+          </a:xfrm>
+          <a:prstGeom prst="rect">
+            <a:avLst/>
+          </a:prstGeom>
+          <a:noFill/>
+          <a:ln/>
+        </p:spPr>
+        <p:txBody>
+          <a:bodyPr wrap="square" lIns="25400" tIns="25400" rIns="25400" bIns="25400" rtlCol="0" anchor="ctr"/>
+          <a:lstStyle/>
+          <a:p>
+            <a:pPr marL="0" indent="0" algn="ctr">
+              <a:buNone/>
+            </a:pPr>
+            <a:r>
+              <a:rPr lang="en-US" sz="1250" b="1" dirty="0">
+                <a:solidFill>
+                  <a:schemeClr val="tx1"/>
+                </a:solidFill>
+              </a:rPr>
+              <a:t>MCP agent</a:t>
+            </a:r>
+            <a:endParaRPr lang="en-US" sz="1250" dirty="0"/>
+          </a:p>
+        </p:txBody>
+      </p:sp>
+      <p:sp>
+        <p:nvSpPr>
+          <p:cNvPr id="6" name="Shape 4"/>
+          <p:cNvSpPr/>
+          <p:nvPr/>
+        </p:nvSpPr>
+        <p:spPr>
+          <a:xfrm>
+            <a:off x="2002536" y="1600200"/>
+            <a:ext cx="192024" cy="0"/>
+          </a:xfrm>
+          <a:prstGeom prst="line">
+            <a:avLst/>
+          </a:prstGeom>
+          <a:noFill/>
+          <a:ln w="15875">
+            <a:solidFill>
+              <a:schemeClr val="accent1"/>
+            </a:solidFill>
+            <a:prstDash val="solid"/>
+            <a:tailEnd type="triangle"/>
+          </a:ln>
+        </p:spPr>
+        <p:txBody>
+          <a:bodyPr/>
+          <a:lstStyle/>
+          <a:p>
+            <a:endParaRPr lang="en-US"/>
+          </a:p>
+        </p:txBody>
+      </p:sp>
+      <p:sp>
+        <p:nvSpPr>
+          <p:cNvPr id="7" name="Box ASP gateway"/>
+          <p:cNvSpPr/>
+          <p:nvPr/>
+        </p:nvSpPr>
+        <p:spPr>
+          <a:xfrm>
+            <a:off x="2212848" y="1371600"/>
+            <a:ext cx="1417320" cy="457200"/>
+          </a:xfrm>
+          <a:prstGeom prst="rect">
+            <a:avLst/>
+          </a:prstGeom>
+          <a:solidFill>
+            <a:schemeClr val="bg2"/>
+          </a:solidFill>
+          <a:ln w="15875">
+            <a:solidFill>
+              <a:schemeClr val="accent1"/>
+            </a:solidFill>
+            <a:prstDash val="solid"/>
+          </a:ln>
+        </p:spPr>
+        <p:txBody>
+          <a:bodyPr/>
+          <a:lstStyle/>
+          <a:p>
+            <a:endParaRPr lang="en-US"/>
+          </a:p>
+        </p:txBody>
+      </p:sp>
+      <p:sp>
+        <p:nvSpPr>
+          <p:cNvPr id="8" name="Text 6"/>
+          <p:cNvSpPr txBox="1"/>
+          <p:nvPr/>
+        </p:nvSpPr>
+        <p:spPr>
+          <a:xfrm>
+            <a:off x="2212848" y="1371600"/>
+            <a:ext cx="1417320" cy="457200"/>
+          </a:xfrm>
+          <a:prstGeom prst="rect">
+            <a:avLst/>
+          </a:prstGeom>
+          <a:noFill/>
+          <a:ln>
+            <a:solidFill>
+              <a:srgbClr val="00B0F0"/>
+            </a:solidFill>
+          </a:ln>
+        </p:spPr>
+        <p:txBody>
+          <a:bodyPr wrap="square" lIns="25400" tIns="25400" rIns="25400" bIns="25400" rtlCol="0" anchor="ctr"/>
+          <a:lstStyle/>
+          <a:p>
+            <a:pPr marL="0" indent="0" algn="ctr">
+              <a:buNone/>
+            </a:pPr>
+            <a:r>
+              <a:rPr lang="en-US" sz="1250" b="1" dirty="0">
+                <a:solidFill>
+                  <a:schemeClr val="tx1"/>
+                </a:solidFill>
+              </a:rPr>
+              <a:t>ASP gateway</a:t>
+            </a:r>
+            <a:endParaRPr lang="en-US" sz="1250" dirty="0"/>
+          </a:p>
+        </p:txBody>
+      </p:sp>
+      <p:sp>
+        <p:nvSpPr>
+          <p:cNvPr id="9" name="Shape 7"/>
+          <p:cNvSpPr/>
+          <p:nvPr/>
+        </p:nvSpPr>
+        <p:spPr>
+          <a:xfrm>
+            <a:off x="3648456" y="1600200"/>
+            <a:ext cx="192024" cy="0"/>
+          </a:xfrm>
+          <a:prstGeom prst="line">
+            <a:avLst/>
+          </a:prstGeom>
+          <a:noFill/>
+          <a:ln w="15875">
+            <a:solidFill>
+              <a:schemeClr val="accent1"/>
+            </a:solidFill>
+            <a:prstDash val="solid"/>
+            <a:tailEnd type="triangle"/>
+          </a:ln>
+        </p:spPr>
+        <p:txBody>
+          <a:bodyPr/>
+          <a:lstStyle/>
+          <a:p>
+            <a:endParaRPr lang="en-US"/>
+          </a:p>
+        </p:txBody>
+      </p:sp>
+      <p:sp>
+        <p:nvSpPr>
+          <p:cNvPr id="10" name="Box Sentinel"/>
+          <p:cNvSpPr/>
+          <p:nvPr/>
+        </p:nvSpPr>
+        <p:spPr>
+          <a:xfrm>
+            <a:off x="3858768" y="1371600"/>
+            <a:ext cx="1417320" cy="457200"/>
+          </a:xfrm>
+          <a:prstGeom prst="rect">
+            <a:avLst/>
+          </a:prstGeom>
+          <a:solidFill>
+            <a:schemeClr val="bg2"/>
+          </a:solidFill>
+          <a:ln/>
+        </p:spPr>
+        <p:txBody>
+          <a:bodyPr/>
+          <a:lstStyle/>
+          <a:p>
+            <a:endParaRPr lang="en-US"/>
+          </a:p>
+        </p:txBody>
+      </p:sp>
+      <p:sp>
+        <p:nvSpPr>
+          <p:cNvPr id="11" name="Text 9"/>
+          <p:cNvSpPr txBox="1"/>
+          <p:nvPr/>
+        </p:nvSpPr>
+        <p:spPr>
+          <a:xfrm>
+            <a:off x="3858768" y="1371600"/>
+            <a:ext cx="1417320" cy="457200"/>
+          </a:xfrm>
+          <a:prstGeom prst="rect">
+            <a:avLst/>
+          </a:prstGeom>
+          <a:noFill/>
+          <a:ln/>
+        </p:spPr>
+        <p:txBody>
+          <a:bodyPr wrap="square" lIns="25400" tIns="25400" rIns="25400" bIns="25400" rtlCol="0" anchor="ctr"/>
+          <a:lstStyle/>
+          <a:p>
+            <a:pPr marL="0" indent="0" algn="ctr">
+              <a:buNone/>
+            </a:pPr>
+            <a:r>
+              <a:rPr lang="en-US" sz="1250" b="1" dirty="0">
+                <a:solidFill>
+                  <a:schemeClr val="tx1"/>
+                </a:solidFill>
+              </a:rPr>
+              <a:t>Content inspection</a:t>
+            </a:r>
+            <a:endParaRPr lang="en-US" sz="1250" dirty="0"/>
+          </a:p>
+        </p:txBody>
+      </p:sp>
+      <p:sp>
+        <p:nvSpPr>
+          <p:cNvPr id="12" name="Shape 10"/>
+          <p:cNvSpPr/>
+          <p:nvPr/>
+        </p:nvSpPr>
+        <p:spPr>
+          <a:xfrm>
+            <a:off x="5294376" y="1600200"/>
+            <a:ext cx="192024" cy="0"/>
+          </a:xfrm>
+          <a:prstGeom prst="line">
+            <a:avLst/>
+          </a:prstGeom>
+          <a:noFill/>
+          <a:ln w="15875">
+            <a:solidFill>
+              <a:srgbClr val="00B050"/>
+            </a:solidFill>
+            <a:prstDash val="solid"/>
+            <a:tailEnd type="triangle"/>
+          </a:ln>
+        </p:spPr>
+        <p:txBody>
+          <a:bodyPr/>
+          <a:lstStyle/>
+          <a:p>
+            <a:endParaRPr lang="en-US"/>
+          </a:p>
+        </p:txBody>
+      </p:sp>
+      <p:sp>
+        <p:nvSpPr>
+          <p:cNvPr id="13" name="Box Flight recorder"/>
+          <p:cNvSpPr/>
+          <p:nvPr/>
+        </p:nvSpPr>
+        <p:spPr>
+          <a:xfrm>
+            <a:off x="5504688" y="1371600"/>
+            <a:ext cx="1417320" cy="457200"/>
+          </a:xfrm>
+          <a:prstGeom prst="rect">
+            <a:avLst/>
+          </a:prstGeom>
+          <a:solidFill>
+            <a:schemeClr val="bg2"/>
+          </a:solidFill>
+          <a:ln/>
+        </p:spPr>
+        <p:txBody>
+          <a:bodyPr/>
+          <a:lstStyle/>
+          <a:p>
+            <a:endParaRPr lang="en-US"/>
+          </a:p>
+        </p:txBody>
+      </p:sp>
+      <p:sp>
+        <p:nvSpPr>
+          <p:cNvPr id="14" name="Text 12"/>
+          <p:cNvSpPr txBox="1"/>
+          <p:nvPr/>
+        </p:nvSpPr>
+        <p:spPr>
+          <a:xfrm>
+            <a:off x="5504688" y="1371600"/>
+            <a:ext cx="1417320" cy="457200"/>
+          </a:xfrm>
+          <a:prstGeom prst="rect">
+            <a:avLst/>
+          </a:prstGeom>
+          <a:noFill/>
+          <a:ln/>
+        </p:spPr>
+        <p:txBody>
+          <a:bodyPr wrap="square" lIns="25400" tIns="25400" rIns="25400" bIns="25400" rtlCol="0" anchor="ctr"/>
+          <a:lstStyle/>
+          <a:p>
+            <a:pPr marL="0" indent="0" algn="ctr">
+              <a:buNone/>
+            </a:pPr>
+            <a:r>
+              <a:rPr lang="en-US" sz="1250" b="1" dirty="0">
+                <a:solidFill>
+                  <a:schemeClr val="tx1"/>
+                </a:solidFill>
+              </a:rPr>
+              <a:t>MCP server</a:t>
+            </a:r>
+            <a:endParaRPr lang="en-US" sz="1250" dirty="0"/>
+          </a:p>
+        </p:txBody>
+      </p:sp>
+      <p:sp>
+        <p:nvSpPr>
+          <p:cNvPr id="15" name="Shape 13"/>
+          <p:cNvSpPr/>
+          <p:nvPr/>
+        </p:nvSpPr>
+        <p:spPr>
+          <a:xfrm>
+            <a:off x="6940296" y="1600200"/>
+            <a:ext cx="192024" cy="0"/>
+          </a:xfrm>
+          <a:prstGeom prst="line">
+            <a:avLst/>
+          </a:prstGeom>
+          <a:noFill/>
+          <a:ln w="15875">
+            <a:solidFill>
+              <a:schemeClr val="accent1"/>
+            </a:solidFill>
+            <a:prstDash val="solid"/>
+            <a:tailEnd type="triangle"/>
+          </a:ln>
+        </p:spPr>
+        <p:txBody>
+          <a:bodyPr/>
+          <a:lstStyle/>
+          <a:p>
+            <a:endParaRPr lang="en-US"/>
+          </a:p>
+        </p:txBody>
+      </p:sp>
+      <p:sp>
+        <p:nvSpPr>
+          <p:cNvPr id="16" name="Box Live dashboard"/>
+          <p:cNvSpPr/>
+          <p:nvPr/>
+        </p:nvSpPr>
+        <p:spPr>
+          <a:xfrm>
+            <a:off x="7150608" y="1371600"/>
+            <a:ext cx="1417320" cy="457200"/>
+          </a:xfrm>
+          <a:prstGeom prst="rect">
+            <a:avLst/>
+          </a:prstGeom>
+          <a:solidFill>
+            <a:schemeClr val="bg2"/>
+          </a:solidFill>
+          <a:ln/>
+        </p:spPr>
+        <p:txBody>
+          <a:bodyPr/>
+          <a:lstStyle/>
+          <a:p>
+            <a:endParaRPr lang="en-US"/>
+          </a:p>
+        </p:txBody>
+      </p:sp>
+      <p:sp>
+        <p:nvSpPr>
+          <p:cNvPr id="17" name="Text 15"/>
+          <p:cNvSpPr txBox="1"/>
+          <p:nvPr/>
+        </p:nvSpPr>
+        <p:spPr>
+          <a:xfrm>
+            <a:off x="7150608" y="1371600"/>
+            <a:ext cx="1417320" cy="457200"/>
+          </a:xfrm>
+          <a:prstGeom prst="rect">
+            <a:avLst/>
+          </a:prstGeom>
+          <a:noFill/>
+          <a:ln/>
+        </p:spPr>
+        <p:txBody>
+          <a:bodyPr wrap="square" lIns="25400" tIns="25400" rIns="25400" bIns="25400" rtlCol="0" anchor="ctr"/>
+          <a:lstStyle/>
+          <a:p>
+            <a:pPr marL="0" indent="0" algn="ctr">
+              <a:buNone/>
+            </a:pPr>
+            <a:r>
+              <a:rPr lang="en-US" sz="1250" b="1" dirty="0">
+                <a:solidFill>
+                  <a:schemeClr val="tx1"/>
+                </a:solidFill>
+              </a:rPr>
+              <a:t>Flight recorder</a:t>
+            </a:r>
+            <a:endParaRPr lang="en-US" sz="1250" dirty="0"/>
+          </a:p>
+        </p:txBody>
+      </p:sp>
+      <p:sp>
+        <p:nvSpPr>
+          <p:cNvPr id="18" name="Shape 16"/>
+          <p:cNvSpPr/>
+          <p:nvPr/>
+        </p:nvSpPr>
+        <p:spPr>
+          <a:xfrm>
+            <a:off x="2921508" y="1828800"/>
+            <a:ext cx="0" cy="457200"/>
+          </a:xfrm>
+          <a:prstGeom prst="line">
+            <a:avLst/>
+          </a:prstGeom>
+          <a:noFill/>
+          <a:ln w="12700">
+            <a:solidFill>
+              <a:srgbClr val="00B0F0"/>
+            </a:solidFill>
+            <a:prstDash val="dash"/>
+            <a:headEnd type="triangle"/>
+          </a:ln>
+        </p:spPr>
+        <p:txBody>
+          <a:bodyPr/>
+          <a:lstStyle/>
+          <a:p>
+            <a:endParaRPr lang="en-US"/>
+          </a:p>
+        </p:txBody>
+      </p:sp>
+      <p:sp>
+        <p:nvSpPr>
+          <p:cNvPr id="19" name="Text 17"/>
+          <p:cNvSpPr txBox="1"/>
+          <p:nvPr/>
+        </p:nvSpPr>
+        <p:spPr>
+          <a:xfrm>
+            <a:off x="2052828" y="2304288"/>
+            <a:ext cx="1737360" cy="237744"/>
+          </a:xfrm>
+          <a:prstGeom prst="rect">
+            <a:avLst/>
+          </a:prstGeom>
+          <a:noFill/>
+          <a:ln/>
+        </p:spPr>
+        <p:txBody>
+          <a:bodyPr wrap="square" lIns="0" tIns="0" rIns="0" bIns="0" rtlCol="0" anchor="ctr"/>
+          <a:lstStyle/>
+          <a:p>
+            <a:pPr marL="0" indent="0" algn="ctr">
+              <a:buNone/>
+            </a:pPr>
+            <a:r>
+              <a:rPr lang="en-US" sz="1050" dirty="0">
+                <a:solidFill>
+                  <a:schemeClr val="tx2"/>
+                </a:solidFill>
+              </a:rPr>
+              <a:t>engine-issued credential</a:t>
+            </a:r>
+            <a:endParaRPr lang="en-US" sz="1050" dirty="0"/>
+          </a:p>
+        </p:txBody>
+      </p:sp>
+      <p:sp>
+        <p:nvSpPr>
+          <p:cNvPr id="20" name="Shape 18"/>
+          <p:cNvSpPr/>
+          <p:nvPr/>
+        </p:nvSpPr>
+        <p:spPr>
+          <a:xfrm>
+            <a:off x="4567428" y="1828800"/>
+            <a:ext cx="0" cy="457200"/>
+          </a:xfrm>
+          <a:prstGeom prst="line">
+            <a:avLst/>
+          </a:prstGeom>
+          <a:noFill/>
+          <a:ln w="12700">
+            <a:solidFill>
+              <a:srgbClr val="00B0F0"/>
+            </a:solidFill>
+            <a:prstDash val="dash"/>
+            <a:headEnd type="triangle"/>
+          </a:ln>
+        </p:spPr>
+        <p:txBody>
+          <a:bodyPr/>
+          <a:lstStyle/>
+          <a:p>
+            <a:endParaRPr lang="en-US"/>
+          </a:p>
+        </p:txBody>
+      </p:sp>
+      <p:sp>
+        <p:nvSpPr>
+          <p:cNvPr id="21" name="Text 19"/>
+          <p:cNvSpPr txBox="1"/>
+          <p:nvPr/>
+        </p:nvSpPr>
+        <p:spPr>
+          <a:xfrm>
+            <a:off x="3698748" y="2304288"/>
+            <a:ext cx="1737360" cy="237744"/>
+          </a:xfrm>
+          <a:prstGeom prst="rect">
+            <a:avLst/>
+          </a:prstGeom>
+          <a:noFill/>
+          <a:ln/>
+        </p:spPr>
+        <p:txBody>
+          <a:bodyPr wrap="square" lIns="0" tIns="0" rIns="0" bIns="0" rtlCol="0" anchor="ctr"/>
+          <a:lstStyle/>
+          <a:p>
+            <a:pPr marL="0" indent="0" algn="ctr">
+              <a:buNone/>
+            </a:pPr>
+            <a:r>
+              <a:rPr lang="en-US" sz="1050" dirty="0">
+                <a:solidFill>
+                  <a:schemeClr val="tx2"/>
+                </a:solidFill>
+              </a:rPr>
+              <a:t>secrets, PII, injections</a:t>
+            </a:r>
+            <a:endParaRPr lang="en-US" sz="1050" dirty="0"/>
+          </a:p>
+        </p:txBody>
+      </p:sp>
+      <p:sp>
+        <p:nvSpPr>
+          <p:cNvPr id="22" name="Text 20"/>
+          <p:cNvSpPr txBox="1"/>
+          <p:nvPr/>
+        </p:nvSpPr>
+        <p:spPr>
+          <a:xfrm>
+            <a:off x="566928" y="2697480"/>
+            <a:ext cx="8001000" cy="1920240"/>
+          </a:xfrm>
+          <a:prstGeom prst="rect">
+            <a:avLst/>
+          </a:prstGeom>
+          <a:noFill/>
+          <a:ln/>
+        </p:spPr>
+        <p:txBody>
+          <a:bodyPr wrap="square" lIns="0" tIns="0" rIns="0" bIns="0" rtlCol="0" anchor="t"/>
+          <a:lstStyle/>
+          <a:p>
+            <a:pPr marL="177800" indent="-177800">
+              <a:spcAft>
+                <a:spcPts val="600"/>
+              </a:spcAft>
+              <a:buClr>
+                <a:schemeClr val="accent1"/>
+              </a:buClr>
+              <a:buSzPct val="100000"/>
+              <a:buChar char="•"/>
+            </a:pPr>
+            <a:r>
+              <a:rPr lang="en-US" sz="1580" dirty="0">
+                <a:solidFill>
+                  <a:schemeClr val="tx1"/>
+                </a:solidFill>
+              </a:rPr>
+              <a:t>The engine mints each agent's credential at spawn, so identity and lineage never come from the agent</a:t>
+            </a:r>
+            <a:endParaRPr lang="en-US" sz="1580" dirty="0"/>
+          </a:p>
+          <a:p>
+            <a:pPr marL="177800" indent="-177800">
+              <a:spcAft>
+                <a:spcPts val="600"/>
+              </a:spcAft>
+              <a:buClr>
+                <a:schemeClr val="accent1"/>
+              </a:buClr>
+              <a:buSzPct val="100000"/>
+              <a:buChar char="•"/>
+            </a:pPr>
+            <a:r>
+              <a:rPr lang="en-US" sz="1580" dirty="0">
+                <a:solidFill>
+                  <a:schemeClr val="tx1"/>
+                </a:solidFill>
+              </a:rPr>
+              <a:t>Tool semantics come from the policy file; undeclared tools are hidden and refused</a:t>
+            </a:r>
+            <a:endParaRPr lang="en-US" sz="1580" dirty="0"/>
+          </a:p>
+          <a:p>
+            <a:pPr marL="177800" indent="-177800">
+              <a:spcAft>
+                <a:spcPts val="600"/>
+              </a:spcAft>
+              <a:buClr>
+                <a:schemeClr val="accent1"/>
+              </a:buClr>
+              <a:buSzPct val="100000"/>
+              <a:buChar char="•"/>
+            </a:pPr>
+            <a:r>
+              <a:rPr lang="en-US" sz="1580" dirty="0">
+                <a:solidFill>
+                  <a:schemeClr val="tx1"/>
+                </a:solidFill>
+              </a:rPr>
+              <a:t>A refused call never reaches the server; allowed calls run in the engine and their outcome is engine-observed</a:t>
+            </a:r>
+            <a:endParaRPr lang="en-US" sz="1580" dirty="0"/>
+          </a:p>
+          <a:p>
+            <a:pPr marL="177800" indent="-177800">
+              <a:spcAft>
+                <a:spcPts val="600"/>
+              </a:spcAft>
+              <a:buClr>
+                <a:schemeClr val="accent1"/>
+              </a:buClr>
+              <a:buSzPct val="100000"/>
+              <a:buChar char="•"/>
+            </a:pPr>
+            <a:r>
+              <a:rPr lang="en-US" sz="1580" dirty="0">
+                <a:solidFill>
+                  <a:schemeClr val="tx1"/>
+                </a:solidFill>
+              </a:rPr>
+              <a:t>Claude Agent SDK, LangChain and Claude Code connect through it. It binds only when the proxy is the agent's sole tool route</a:t>
+            </a:r>
+            <a:endParaRPr lang="en-US" sz="1580" dirty="0"/>
+          </a:p>
+        </p:txBody>
+      </p:sp>
+    </p:spTree>
+  </p:cSld>
+  <p:clrMapOvr>
+    <a:masterClrMapping/>
+  </p:clrMapOvr>
+</p:sld>
+</file>
+
 <file path=ppt/slides/slide2.xml><?xml version="1.0" encoding="utf-8"?>
 <p:sld xmlns:a="http://schemas.openxmlformats.org/drawingml/2006/main" xmlns:r="http://schemas.openxmlformats.org/officeDocument/2006/relationships" xmlns:p="http://schemas.openxmlformats.org/presentationml/2006/main">
   <p:cSld name="Slide 2">
@@ -7919,7 +8823,7 @@
                 <a:ea typeface="JetBrains Mono" pitchFamily="34" charset="-122"/>
                 <a:cs typeface="JetBrains Mono" pitchFamily="34" charset="-120"/>
               </a:rPr>
-              <a:t>02 / 16</a:t>
+              <a:t>02 / 17</a:t>
             </a:r>
             <a:endParaRPr lang="en-US" sz="1130" dirty="0"/>
           </a:p>
@@ -8435,7 +9339,7 @@
                 <a:ea typeface="JetBrains Mono" pitchFamily="34" charset="-122"/>
                 <a:cs typeface="JetBrains Mono" pitchFamily="34" charset="-120"/>
               </a:rPr>
-              <a:t>03 / 16</a:t>
+              <a:t>03 / 17</a:t>
             </a:r>
             <a:endParaRPr lang="en-US" sz="1130" dirty="0"/>
           </a:p>
@@ -9561,7 +10465,7 @@
                 <a:ea typeface="JetBrains Mono" pitchFamily="34" charset="-122"/>
                 <a:cs typeface="JetBrains Mono" pitchFamily="34" charset="-120"/>
               </a:rPr>
-              <a:t>04 / 16</a:t>
+              <a:t>04 / 17</a:t>
             </a:r>
             <a:endParaRPr lang="en-US" sz="1130" dirty="0"/>
           </a:p>
@@ -10793,7 +11697,7 @@
                           <a:ea typeface="IBM Plex Sans" pitchFamily="34" charset="-122"/>
                           <a:cs typeface="IBM Plex Sans" pitchFamily="34" charset="-120"/>
                         </a:rPr>
-                        <a:t>Argument rules on credential stores</a:t>
+                        <a:t>Argument rules; content inspection of arguments and MCP results</a:t>
                       </a:r>
                       <a:endParaRPr lang="en-US" sz="1250" dirty="0">
                         <a:latin typeface="IBM Plex Sans" charset="0"/>
@@ -10861,7 +11765,7 @@
                           <a:ea typeface="IBM Plex Sans" pitchFamily="34" charset="-122"/>
                           <a:cs typeface="IBM Plex Sans" pitchFamily="34" charset="-120"/>
                         </a:rPr>
-                        <a:t>Report-only</a:t>
+                        <a:t>Opt-in</a:t>
                       </a:r>
                       <a:endParaRPr lang="en-US" sz="1250" dirty="0">
                         <a:latin typeface="IBM Plex Sans" charset="0"/>
@@ -11426,7 +12330,7 @@
                           <a:ea typeface="IBM Plex Sans" pitchFamily="34" charset="-122"/>
                           <a:cs typeface="IBM Plex Sans" pitchFamily="34" charset="-120"/>
                         </a:rPr>
-                        <a:t>Authenticated sessions; demo tools run only inside the engine</a:t>
+                        <a:t>Engine-owned demo tools; MCP proxy with engine-issued credentials</a:t>
                       </a:r>
                       <a:endParaRPr lang="en-US" sz="1250" dirty="0">
                         <a:latin typeface="IBM Plex Sans" charset="0"/>
@@ -11613,7 +12517,7 @@
                 <a:ea typeface="JetBrains Mono" pitchFamily="34" charset="-122"/>
                 <a:cs typeface="JetBrains Mono" pitchFamily="34" charset="-120"/>
               </a:rPr>
-              <a:t>05 / 16</a:t>
+              <a:t>05 / 17</a:t>
             </a:r>
             <a:endParaRPr lang="en-US" sz="1130" dirty="0"/>
           </a:p>
@@ -12405,7 +13309,7 @@
                 <a:ea typeface="JetBrains Mono" pitchFamily="34" charset="-122"/>
                 <a:cs typeface="JetBrains Mono" pitchFamily="34" charset="-120"/>
               </a:rPr>
-              <a:t>06 / 16</a:t>
+              <a:t>06 / 17</a:t>
             </a:r>
             <a:endParaRPr lang="en-US" sz="1130" dirty="0"/>
           </a:p>
@@ -13526,7 +14430,7 @@
                 <a:ea typeface="JetBrains Mono" pitchFamily="34" charset="-122"/>
                 <a:cs typeface="JetBrains Mono" pitchFamily="34" charset="-120"/>
               </a:rPr>
-              <a:t>07 / 16</a:t>
+              <a:t>07 / 17</a:t>
             </a:r>
             <a:endParaRPr lang="en-US" sz="1130" dirty="0"/>
           </a:p>
@@ -15210,7 +16114,7 @@
                 <a:ea typeface="JetBrains Mono" pitchFamily="34" charset="-122"/>
                 <a:cs typeface="JetBrains Mono" pitchFamily="34" charset="-120"/>
               </a:rPr>
-              <a:t>08 / 16</a:t>
+              <a:t>08 / 17</a:t>
             </a:r>
             <a:endParaRPr lang="en-US" sz="1130" dirty="0"/>
           </a:p>
@@ -15781,7 +16685,7 @@
                 <a:ea typeface="JetBrains Mono" pitchFamily="34" charset="-122"/>
                 <a:cs typeface="JetBrains Mono" pitchFamily="34" charset="-120"/>
               </a:rPr>
-              <a:t>09 / 16</a:t>
+              <a:t>09 / 17</a:t>
             </a:r>
             <a:endParaRPr lang="en-US" sz="1130" dirty="0"/>
           </a:p>

</xml_diff>